<commit_message>
Remove MX style, prototype, reprint, and copyright lines from the rules booklet.
</commit_message>
<xml_diff>
--- a/output/svet-moy-zerkalce-rules.pptx
+++ b/output/svet-moy-zerkalce-rules.pptx
@@ -3219,7 +3219,7 @@
                 </a:solidFill>
                 <a:latin typeface="Arial"/>
               </a:rPr>
-              <a:t>Версия правил 0.6  ·  стиль редакции МХ (прототип)</a:t>
+              <a:t>Версия правил 0.6</a:t>
             </a:r>
           </a:p>
         </p:txBody>
@@ -6044,7 +6044,7 @@
         <p:spPr>
           <a:xfrm>
             <a:off x="432000" y="2390400"/>
-            <a:ext cx="6696000" cy="1634400"/>
+            <a:ext cx="6696000" cy="964800"/>
           </a:xfrm>
           <a:prstGeom prst="rect">
             <a:avLst/>
@@ -6110,64 +6110,7 @@
                 </a:solidFill>
                 <a:latin typeface="Arial"/>
               </a:rPr>
-              <a:t>Стиль текста правил ориентирован на редакцию ООО «Мир Хобби».</a:t>
-            </a:r>
-          </a:p>
-          <a:p>
-            <a:pPr>
-              <a:spcBef>
-                <a:spcPts val="0"/>
-              </a:spcBef>
-              <a:spcAft>
-                <a:spcPts val="200"/>
-              </a:spcAft>
-            </a:pPr>
-            <a:r>
-              <a:rPr sz="1000" b="0">
-                <a:solidFill>
-                  <a:srgbClr val="1A1A1A"/>
-                </a:solidFill>
-                <a:latin typeface="Arial"/>
-              </a:rPr>
-              <a:t>Это прототип, не коммерческий буклет МХ.</a:t>
-            </a:r>
-          </a:p>
-          <a:p>
-            <a:pPr>
-              <a:spcBef>
-                <a:spcPts val="0"/>
-              </a:spcBef>
-              <a:spcAft>
-                <a:spcPts val="200"/>
-              </a:spcAft>
-            </a:pPr>
-            <a:r>
-              <a:rPr sz="1000" b="0">
-                <a:solidFill>
-                  <a:srgbClr val="1A1A1A"/>
-                </a:solidFill>
-                <a:latin typeface="Arial"/>
-              </a:rPr>
-              <a:t>Перепечатка и публикация без разрешения автора запрещены.</a:t>
-            </a:r>
-          </a:p>
-          <a:p>
-            <a:pPr>
-              <a:spcBef>
-                <a:spcPts val="0"/>
-              </a:spcBef>
-              <a:spcAft>
-                <a:spcPts val="200"/>
-              </a:spcAft>
-            </a:pPr>
-            <a:r>
-              <a:rPr sz="1000" b="0">
-                <a:solidFill>
-                  <a:srgbClr val="1A1A1A"/>
-                </a:solidFill>
-                <a:latin typeface="Arial"/>
-              </a:rPr>
-              <a:t>© 2026 Юрий Ямщиков. Версия правил 0.6</a:t>
+              <a:t>Версия правил 0.6</a:t>
             </a:r>
           </a:p>
           <a:p>
@@ -6199,7 +6142,7 @@
         </p:nvSpPr>
         <p:spPr>
           <a:xfrm>
-            <a:off x="432000" y="4060800"/>
+            <a:off x="432000" y="3391200"/>
             <a:ext cx="6696000" cy="288000"/>
           </a:xfrm>
           <a:prstGeom prst="rect">
@@ -6233,7 +6176,7 @@
         </p:nvSpPr>
         <p:spPr>
           <a:xfrm>
-            <a:off x="432000" y="4348800"/>
+            <a:off x="432000" y="3679200"/>
             <a:ext cx="6696000" cy="1025280"/>
           </a:xfrm>
           <a:prstGeom prst="rect">
@@ -6332,7 +6275,7 @@
         </p:nvSpPr>
         <p:spPr>
           <a:xfrm>
-            <a:off x="432000" y="5410080"/>
+            <a:off x="432000" y="4740480"/>
             <a:ext cx="6696000" cy="310320"/>
           </a:xfrm>
           <a:prstGeom prst="rect">
@@ -6382,7 +6325,7 @@
         </p:blipFill>
         <p:spPr>
           <a:xfrm>
-            <a:off x="432000" y="5756400"/>
+            <a:off x="432000" y="5086800"/>
             <a:ext cx="6696000" cy="4276556"/>
           </a:xfrm>
           <a:prstGeom prst="rect">

</xml_diff>

<commit_message>
Rewrite rules booklet 3.7: layout, duplex комплектация, voting example.
</commit_message>
<xml_diff>
--- a/output/svet-moy-zerkalce-rules.pptx
+++ b/output/svet-moy-zerkalce-rules.pptx
@@ -3100,7 +3100,7 @@
         <p:spPr>
           <a:xfrm>
             <a:off x="432000" y="432000"/>
-            <a:ext cx="6696000" cy="396000"/>
+            <a:ext cx="6696000" cy="504000"/>
           </a:xfrm>
           <a:prstGeom prst="rect">
             <a:avLst/>
@@ -3114,13 +3114,13 @@
           <a:lstStyle/>
           <a:p>
             <a:r>
-              <a:rPr sz="1800" b="1">
+              <a:rPr sz="1800" b="1" i="0">
                 <a:solidFill>
                   <a:srgbClr val="1A1A1A"/>
                 </a:solidFill>
                 <a:latin typeface="Arial"/>
               </a:rPr>
-              <a:t>Свет мой зеркальце</a:t>
+              <a:t>Свет мой зеркальце. Правила игры</a:t>
             </a:r>
           </a:p>
         </p:txBody>
@@ -3133,8 +3133,8 @@
         </p:nvSpPr>
         <p:spPr>
           <a:xfrm>
-            <a:off x="432000" y="864000"/>
-            <a:ext cx="6696000" cy="1085760"/>
+            <a:off x="432000" y="972000"/>
+            <a:ext cx="6696000" cy="578879"/>
           </a:xfrm>
           <a:prstGeom prst="rect">
             <a:avLst/>
@@ -3156,13 +3156,13 @@
               </a:spcAft>
             </a:pPr>
             <a:r>
-              <a:rPr sz="1200" b="0">
+              <a:rPr sz="1200" b="0" i="0">
                 <a:solidFill>
                   <a:srgbClr val="1A1A1A"/>
                 </a:solidFill>
                 <a:latin typeface="Arial"/>
               </a:rPr>
-              <a:t>ПРАВИЛА ИГРЫ</a:t>
+              <a:t>3–6 игроков  ·  от 16 лет  ·  около 30 минут</a:t>
             </a:r>
           </a:p>
           <a:p>
@@ -3175,15 +3175,38 @@
               </a:spcAft>
             </a:pPr>
             <a:r>
-              <a:rPr sz="1200" b="0">
+              <a:rPr sz="1200" b="0" i="0">
                 <a:solidFill>
                   <a:srgbClr val="1A1A1A"/>
                 </a:solidFill>
                 <a:latin typeface="Arial"/>
               </a:rPr>
-              <a:t>3–6 игроков  ·  от 16 лет  ·  около 30 минут</a:t>
-            </a:r>
-          </a:p>
+              <a:t>Версия правил 3.7</a:t>
+            </a:r>
+          </a:p>
+        </p:txBody>
+      </p:sp>
+      <p:sp>
+        <p:nvSpPr>
+          <p:cNvPr id="4" name="TextBox 3"/>
+          <p:cNvSpPr txBox="1"/>
+          <p:nvPr/>
+        </p:nvSpPr>
+        <p:spPr>
+          <a:xfrm>
+            <a:off x="432000" y="1586880"/>
+            <a:ext cx="6696000" cy="310320"/>
+          </a:xfrm>
+          <a:prstGeom prst="rect">
+            <a:avLst/>
+          </a:prstGeom>
+          <a:noFill/>
+        </p:spPr>
+        <p:txBody>
+          <a:bodyPr wrap="square" anchor="t" lIns="0" rIns="0" tIns="0" bIns="0">
+            <a:spAutoFit/>
+          </a:bodyPr>
+          <a:lstStyle/>
           <a:p>
             <a:pPr>
               <a:spcBef>
@@ -3194,45 +3217,26 @@
               </a:spcAft>
             </a:pPr>
             <a:r>
-              <a:rPr sz="1200" b="0">
+              <a:rPr sz="1100" b="0" i="1">
                 <a:solidFill>
                   <a:srgbClr val="1A1A1A"/>
                 </a:solidFill>
                 <a:latin typeface="Arial"/>
               </a:rPr>
-              <a:t>Контакты автора: yury.yamshchikov@gmail.com</a:t>
-            </a:r>
-          </a:p>
-          <a:p>
-            <a:pPr>
-              <a:spcBef>
-                <a:spcPts val="0"/>
-              </a:spcBef>
-              <a:spcAft>
-                <a:spcPts val="200"/>
-              </a:spcAft>
-            </a:pPr>
-            <a:r>
-              <a:rPr sz="1200" b="0">
-                <a:solidFill>
-                  <a:srgbClr val="1A1A1A"/>
-                </a:solidFill>
-                <a:latin typeface="Arial"/>
-              </a:rPr>
-              <a:t>Версия правил 0.6</a:t>
-            </a:r>
-          </a:p>
-        </p:txBody>
-      </p:sp>
-      <p:sp>
-        <p:nvSpPr>
-          <p:cNvPr id="4" name="TextBox 3"/>
+              <a:t>Вы – гремлины службы поддержки волшебного сервиса «Свет мой зеркальце скажи». Клиенты из почти современного мира задают через зеркало странные вопросы, а вы на лету собираете ответы из карт букв, которые берёте из общей кучи в центре стола. Чем смешнее и точнее реакция зала – тем выше шанс забрать карту запроса себе. Побеждает тот, у кого к концу колоды запросов больше всего таких карт.</a:t>
+            </a:r>
+          </a:p>
+        </p:txBody>
+      </p:sp>
+      <p:sp>
+        <p:nvSpPr>
+          <p:cNvPr id="5" name="TextBox 4"/>
           <p:cNvSpPr txBox="1"/>
           <p:nvPr/>
         </p:nvSpPr>
         <p:spPr>
           <a:xfrm>
-            <a:off x="432000" y="1985759"/>
+            <a:off x="432000" y="1933200"/>
             <a:ext cx="6696000" cy="288000"/>
           </a:xfrm>
           <a:prstGeom prst="rect">
@@ -3247,328 +3251,20 @@
           <a:lstStyle/>
           <a:p>
             <a:r>
-              <a:rPr sz="1200" b="1">
+              <a:rPr sz="1200" b="1" i="0">
                 <a:solidFill>
                   <a:srgbClr val="2E5A88"/>
                 </a:solidFill>
                 <a:latin typeface="Arial"/>
               </a:rPr>
-              <a:t>ОБ ИГРЕ</a:t>
-            </a:r>
-          </a:p>
-        </p:txBody>
-      </p:sp>
-      <p:sp>
-        <p:nvSpPr>
-          <p:cNvPr id="5" name="TextBox 4"/>
-          <p:cNvSpPr txBox="1"/>
-          <p:nvPr/>
-        </p:nvSpPr>
-        <p:spPr>
-          <a:xfrm>
-            <a:off x="432000" y="2273760"/>
-            <a:ext cx="6696000" cy="1978560"/>
-          </a:xfrm>
-          <a:prstGeom prst="rect">
-            <a:avLst/>
-          </a:prstGeom>
-          <a:noFill/>
-        </p:spPr>
-        <p:txBody>
-          <a:bodyPr wrap="square" anchor="t" lIns="0" rIns="0" tIns="0" bIns="0">
-            <a:spAutoFit/>
-          </a:bodyPr>
-          <a:lstStyle/>
-          <a:p>
-            <a:pPr>
-              <a:spcBef>
-                <a:spcPts val="0"/>
-              </a:spcBef>
-              <a:spcAft>
-                <a:spcPts val="200"/>
-              </a:spcAft>
-            </a:pPr>
-            <a:r>
-              <a:rPr sz="1100" b="0">
-                <a:solidFill>
-                  <a:srgbClr val="1A1A1A"/>
-                </a:solidFill>
-                <a:latin typeface="Arial"/>
-              </a:rPr>
-              <a:t>Вы – гремлины службы поддержки волшебного сервиса «Зеркальце».</a:t>
-            </a:r>
-          </a:p>
-          <a:p>
-            <a:pPr>
-              <a:spcBef>
-                <a:spcPts val="0"/>
-              </a:spcBef>
-              <a:spcAft>
-                <a:spcPts val="200"/>
-              </a:spcAft>
-            </a:pPr>
-            <a:r>
-              <a:rPr sz="1100" b="0">
-                <a:solidFill>
-                  <a:srgbClr val="1A1A1A"/>
-                </a:solidFill>
-                <a:latin typeface="Arial"/>
-              </a:rPr>
-              <a:t>Клиенты задают через зеркало странные вопросы, а вы на лету</a:t>
-            </a:r>
-          </a:p>
-          <a:p>
-            <a:pPr>
-              <a:spcBef>
-                <a:spcPts val="0"/>
-              </a:spcBef>
-              <a:spcAft>
-                <a:spcPts val="200"/>
-              </a:spcAft>
-            </a:pPr>
-            <a:r>
-              <a:rPr sz="1100" b="0">
-                <a:solidFill>
-                  <a:srgbClr val="1A1A1A"/>
-                </a:solidFill>
-                <a:latin typeface="Arial"/>
-              </a:rPr>
-              <a:t>собираете ответы из карт букв, которые берёте из общей кучи.</a:t>
-            </a:r>
-          </a:p>
-          <a:p>
-            <a:pPr>
-              <a:spcBef>
-                <a:spcPts val="0"/>
-              </a:spcBef>
-              <a:spcAft>
-                <a:spcPts val="200"/>
-              </a:spcAft>
-            </a:pPr>
-            <a:r>
-              <a:rPr sz="1100" b="0">
-                <a:solidFill>
-                  <a:srgbClr val="1A1A1A"/>
-                </a:solidFill>
-                <a:latin typeface="Arial"/>
-              </a:rPr>
-              <a:t>Чем смешнее и точнее реакция зала – тем выше шанс забрать</a:t>
-            </a:r>
-          </a:p>
-          <a:p>
-            <a:pPr>
-              <a:spcBef>
-                <a:spcPts val="0"/>
-              </a:spcBef>
-              <a:spcAft>
-                <a:spcPts val="200"/>
-              </a:spcAft>
-            </a:pPr>
-            <a:r>
-              <a:rPr sz="1100" b="0">
-                <a:solidFill>
-                  <a:srgbClr val="1A1A1A"/>
-                </a:solidFill>
-                <a:latin typeface="Arial"/>
-              </a:rPr>
-              <a:t>карту запроса себе. Побеждает тот, у кого к концу колоды</a:t>
-            </a:r>
-          </a:p>
-          <a:p>
-            <a:pPr>
-              <a:spcBef>
-                <a:spcPts val="0"/>
-              </a:spcBef>
-              <a:spcAft>
-                <a:spcPts val="200"/>
-              </a:spcAft>
-            </a:pPr>
-            <a:r>
-              <a:rPr sz="1100" b="0">
-                <a:solidFill>
-                  <a:srgbClr val="1A1A1A"/>
-                </a:solidFill>
-                <a:latin typeface="Arial"/>
-              </a:rPr>
-              <a:t>больше всего таких карт.</a:t>
-            </a:r>
-          </a:p>
-          <a:p>
-            <a:pPr>
-              <a:spcBef>
-                <a:spcPts val="0"/>
-              </a:spcBef>
-              <a:spcAft>
-                <a:spcPts val="200"/>
-              </a:spcAft>
-            </a:pPr>
-            <a:r>
-              <a:rPr sz="1100" b="0">
-                <a:solidFill>
-                  <a:srgbClr val="1A1A1A"/>
-                </a:solidFill>
-                <a:latin typeface="Arial"/>
-              </a:rPr>
-              <a:t>Содержание: взрослый и чёрный юмор (в т.ч. намёки на отношения,</a:t>
-            </a:r>
-          </a:p>
-          <a:p>
-            <a:pPr>
-              <a:spcBef>
-                <a:spcPts val="0"/>
-              </a:spcBef>
-              <a:spcAft>
-                <a:spcPts val="200"/>
-              </a:spcAft>
-            </a:pPr>
-            <a:r>
-              <a:rPr sz="1100" b="0">
-                <a:solidFill>
-                  <a:srgbClr val="1A1A1A"/>
-                </a:solidFill>
-                <a:latin typeface="Arial"/>
-              </a:rPr>
-              <a:t>алкоголь и табак). Политика и религия не используются.</a:t>
-            </a:r>
-          </a:p>
-        </p:txBody>
-      </p:sp>
-      <p:sp>
-        <p:nvSpPr>
-          <p:cNvPr id="6" name="TextBox 5"/>
-          <p:cNvSpPr txBox="1"/>
-          <p:nvPr/>
-        </p:nvSpPr>
-        <p:spPr>
-          <a:xfrm>
-            <a:off x="432000" y="4288320"/>
-            <a:ext cx="6696000" cy="288000"/>
-          </a:xfrm>
-          <a:prstGeom prst="rect">
-            <a:avLst/>
-          </a:prstGeom>
-          <a:noFill/>
-        </p:spPr>
-        <p:txBody>
-          <a:bodyPr wrap="square" anchor="t" lIns="0" rIns="0" tIns="0" bIns="0">
-            <a:spAutoFit/>
-          </a:bodyPr>
-          <a:lstStyle/>
-          <a:p>
-            <a:r>
-              <a:rPr sz="1200" b="1">
-                <a:solidFill>
-                  <a:srgbClr val="2E5A88"/>
-                </a:solidFill>
-                <a:latin typeface="Arial"/>
-              </a:rPr>
-              <a:t>СОСТАВ ИГРЫ</a:t>
-            </a:r>
-          </a:p>
-        </p:txBody>
-      </p:sp>
-      <p:sp>
-        <p:nvSpPr>
-          <p:cNvPr id="7" name="TextBox 6"/>
-          <p:cNvSpPr txBox="1"/>
-          <p:nvPr/>
-        </p:nvSpPr>
-        <p:spPr>
-          <a:xfrm>
-            <a:off x="432000" y="4576320"/>
-            <a:ext cx="6696000" cy="1025280"/>
-          </a:xfrm>
-          <a:prstGeom prst="rect">
-            <a:avLst/>
-          </a:prstGeom>
-          <a:noFill/>
-        </p:spPr>
-        <p:txBody>
-          <a:bodyPr wrap="square" anchor="t" lIns="0" rIns="0" tIns="0" bIns="0">
-            <a:spAutoFit/>
-          </a:bodyPr>
-          <a:lstStyle/>
-          <a:p>
-            <a:pPr>
-              <a:spcBef>
-                <a:spcPts val="0"/>
-              </a:spcBef>
-              <a:spcAft>
-                <a:spcPts val="200"/>
-              </a:spcAft>
-            </a:pPr>
-            <a:r>
-              <a:rPr sz="1100" b="0">
-                <a:solidFill>
-                  <a:srgbClr val="1A1A1A"/>
-                </a:solidFill>
-                <a:latin typeface="Arial"/>
-              </a:rPr>
-              <a:t>• 14 карт запросов (двусторонние: начало + окончание фразы)</a:t>
-            </a:r>
-          </a:p>
-          <a:p>
-            <a:pPr>
-              <a:spcBef>
-                <a:spcPts val="0"/>
-              </a:spcBef>
-              <a:spcAft>
-                <a:spcPts val="200"/>
-              </a:spcAft>
-            </a:pPr>
-            <a:r>
-              <a:rPr sz="1100" b="0">
-                <a:solidFill>
-                  <a:srgbClr val="1A1A1A"/>
-                </a:solidFill>
-                <a:latin typeface="Arial"/>
-              </a:rPr>
-              <a:t>• 72 карты букв (частотность русского языка; рубашка = джокер)</a:t>
-            </a:r>
-          </a:p>
-          <a:p>
-            <a:pPr>
-              <a:spcBef>
-                <a:spcPts val="0"/>
-              </a:spcBef>
-              <a:spcAft>
-                <a:spcPts val="200"/>
-              </a:spcAft>
-            </a:pPr>
-            <a:r>
-              <a:rPr sz="1100" b="0">
-                <a:solidFill>
-                  <a:srgbClr val="1A1A1A"/>
-                </a:solidFill>
-                <a:latin typeface="Arial"/>
-              </a:rPr>
-              <a:t>• 6 карт «Ты восхитителен» (по 1 каждого цвета)</a:t>
-            </a:r>
-          </a:p>
-          <a:p>
-            <a:pPr>
-              <a:spcBef>
-                <a:spcPts val="0"/>
-              </a:spcBef>
-              <a:spcAft>
-                <a:spcPts val="200"/>
-              </a:spcAft>
-            </a:pPr>
-            <a:r>
-              <a:rPr sz="1100" b="0">
-                <a:solidFill>
-                  <a:srgbClr val="1A1A1A"/>
-                </a:solidFill>
-                <a:latin typeface="Arial"/>
-              </a:rPr>
-              <a:t>• правила, которые вы читаете</a:t>
+              <a:t>КОМПЛЕКТАЦИЯ</a:t>
             </a:r>
           </a:p>
         </p:txBody>
       </p:sp>
       <p:pic>
         <p:nvPicPr>
-          <p:cNvPr id="8" name="Picture 7" descr="card-request-face.png"/>
+          <p:cNvPr id="6" name="Picture 5" descr="card-request-duplex.png"/>
           <p:cNvPicPr>
             <a:picLocks noChangeAspect="1"/>
           </p:cNvPicPr>
@@ -3582,8 +3278,8 @@
         </p:blipFill>
         <p:spPr>
           <a:xfrm>
-            <a:off x="504000" y="5637600"/>
-            <a:ext cx="1224000" cy="945942"/>
+            <a:off x="417588" y="2857601"/>
+            <a:ext cx="2267799" cy="724278"/>
           </a:xfrm>
           <a:prstGeom prst="rect">
             <a:avLst/>
@@ -3592,14 +3288,14 @@
       </p:pic>
       <p:sp>
         <p:nvSpPr>
-          <p:cNvPr id="9" name="TextBox 8"/>
+          <p:cNvPr id="7" name="TextBox 6"/>
           <p:cNvSpPr txBox="1"/>
           <p:nvPr/>
         </p:nvSpPr>
         <p:spPr>
           <a:xfrm>
-            <a:off x="504000" y="6602589"/>
-            <a:ext cx="1224000" cy="360000"/>
+            <a:off x="417588" y="3596279"/>
+            <a:ext cx="2267799" cy="504000"/>
           </a:xfrm>
           <a:prstGeom prst="rect">
             <a:avLst/>
@@ -3614,20 +3310,20 @@
           <a:p>
             <a:pPr algn="ctr"/>
             <a:r>
-              <a:rPr sz="800" b="0">
+              <a:rPr sz="800" b="0" i="0">
                 <a:solidFill>
                   <a:srgbClr val="555555"/>
                 </a:solidFill>
                 <a:latin typeface="Arial"/>
               </a:rPr>
-              <a:t>запрос · лицо</a:t>
+              <a:t>карты запросов – 14 шт. (лицевая сторона и рубашка)</a:t>
             </a:r>
           </a:p>
         </p:txBody>
       </p:sp>
       <p:pic>
         <p:nvPicPr>
-          <p:cNvPr id="10" name="Picture 9" descr="card-request-back.png"/>
+          <p:cNvPr id="8" name="Picture 7" descr="card-letter-duplex.png"/>
           <p:cNvPicPr>
             <a:picLocks noChangeAspect="1"/>
           </p:cNvPicPr>
@@ -3641,8 +3337,8 @@
         </p:blipFill>
         <p:spPr>
           <a:xfrm>
-            <a:off x="1836000" y="5637600"/>
-            <a:ext cx="1224000" cy="945942"/>
+            <a:off x="2829388" y="2423004"/>
+            <a:ext cx="2267799" cy="1158875"/>
           </a:xfrm>
           <a:prstGeom prst="rect">
             <a:avLst/>
@@ -3651,14 +3347,14 @@
       </p:pic>
       <p:sp>
         <p:nvSpPr>
-          <p:cNvPr id="11" name="TextBox 10"/>
+          <p:cNvPr id="9" name="TextBox 8"/>
           <p:cNvSpPr txBox="1"/>
           <p:nvPr/>
         </p:nvSpPr>
         <p:spPr>
           <a:xfrm>
-            <a:off x="1836000" y="6602589"/>
-            <a:ext cx="1224000" cy="360000"/>
+            <a:off x="2829388" y="3596279"/>
+            <a:ext cx="2267799" cy="504000"/>
           </a:xfrm>
           <a:prstGeom prst="rect">
             <a:avLst/>
@@ -3673,20 +3369,20 @@
           <a:p>
             <a:pPr algn="ctr"/>
             <a:r>
-              <a:rPr sz="800" b="0">
+              <a:rPr sz="800" b="0" i="0">
                 <a:solidFill>
                   <a:srgbClr val="555555"/>
                 </a:solidFill>
                 <a:latin typeface="Arial"/>
               </a:rPr>
-              <a:t>запрос · оборот</a:t>
+              <a:t>карты букв – 72 шт. (рубашка – джокер)</a:t>
             </a:r>
           </a:p>
         </p:txBody>
       </p:sp>
       <p:pic>
         <p:nvPicPr>
-          <p:cNvPr id="12" name="Picture 11" descr="card-letter.png"/>
+          <p:cNvPr id="10" name="Picture 9" descr="card-vote-stack.png"/>
           <p:cNvPicPr>
             <a:picLocks noChangeAspect="1"/>
           </p:cNvPicPr>
@@ -3700,8 +3396,8 @@
         </p:blipFill>
         <p:spPr>
           <a:xfrm>
-            <a:off x="3168000" y="5637600"/>
-            <a:ext cx="1224000" cy="945942"/>
+            <a:off x="5241187" y="2221200"/>
+            <a:ext cx="1901223" cy="1360679"/>
           </a:xfrm>
           <a:prstGeom prst="rect">
             <a:avLst/>
@@ -3710,14 +3406,14 @@
       </p:pic>
       <p:sp>
         <p:nvSpPr>
-          <p:cNvPr id="13" name="TextBox 12"/>
+          <p:cNvPr id="11" name="TextBox 10"/>
           <p:cNvSpPr txBox="1"/>
           <p:nvPr/>
         </p:nvSpPr>
         <p:spPr>
           <a:xfrm>
-            <a:off x="3168000" y="6602589"/>
-            <a:ext cx="1224000" cy="360000"/>
+            <a:off x="5241187" y="3596279"/>
+            <a:ext cx="1901223" cy="504000"/>
           </a:xfrm>
           <a:prstGeom prst="rect">
             <a:avLst/>
@@ -3732,20 +3428,176 @@
           <a:p>
             <a:pPr algn="ctr"/>
             <a:r>
-              <a:rPr sz="800" b="0">
+              <a:rPr sz="800" b="0" i="0">
                 <a:solidFill>
                   <a:srgbClr val="555555"/>
                 </a:solidFill>
                 <a:latin typeface="Arial"/>
               </a:rPr>
-              <a:t>буква</a:t>
+              <a:t>карты «Ты восхитителен» – 6 шт. (по 1 каждого цвета)</a:t>
+            </a:r>
+          </a:p>
+        </p:txBody>
+      </p:sp>
+      <p:sp>
+        <p:nvSpPr>
+          <p:cNvPr id="12" name="TextBox 11"/>
+          <p:cNvSpPr txBox="1"/>
+          <p:nvPr/>
+        </p:nvSpPr>
+        <p:spPr>
+          <a:xfrm>
+            <a:off x="432000" y="4157879"/>
+            <a:ext cx="6696000" cy="295200"/>
+          </a:xfrm>
+          <a:prstGeom prst="rect">
+            <a:avLst/>
+          </a:prstGeom>
+          <a:noFill/>
+        </p:spPr>
+        <p:txBody>
+          <a:bodyPr wrap="square" anchor="t" lIns="0" rIns="0" tIns="0" bIns="0">
+            <a:spAutoFit/>
+          </a:bodyPr>
+          <a:lstStyle/>
+          <a:p>
+            <a:pPr>
+              <a:spcBef>
+                <a:spcPts val="0"/>
+              </a:spcBef>
+              <a:spcAft>
+                <a:spcPts val="200"/>
+              </a:spcAft>
+            </a:pPr>
+            <a:r>
+              <a:rPr sz="1000" b="0" i="0">
+                <a:solidFill>
+                  <a:srgbClr val="1A1A1A"/>
+                </a:solidFill>
+                <a:latin typeface="Arial"/>
+              </a:rPr>
+              <a:t>Элементы, которых нет в PnP, но которые нужны для партии: поверхность стола, достаточная чтобы раскидать карты букв и кидать карты «Ты восхитителен» к игрокам.</a:t>
+            </a:r>
+          </a:p>
+        </p:txBody>
+      </p:sp>
+      <p:sp>
+        <p:nvSpPr>
+          <p:cNvPr id="13" name="TextBox 12"/>
+          <p:cNvSpPr txBox="1"/>
+          <p:nvPr/>
+        </p:nvSpPr>
+        <p:spPr>
+          <a:xfrm>
+            <a:off x="432000" y="4489079"/>
+            <a:ext cx="6696000" cy="288000"/>
+          </a:xfrm>
+          <a:prstGeom prst="rect">
+            <a:avLst/>
+          </a:prstGeom>
+          <a:noFill/>
+        </p:spPr>
+        <p:txBody>
+          <a:bodyPr wrap="square" anchor="t" lIns="0" rIns="0" tIns="0" bIns="0">
+            <a:spAutoFit/>
+          </a:bodyPr>
+          <a:lstStyle/>
+          <a:p>
+            <a:r>
+              <a:rPr sz="1200" b="1" i="0">
+                <a:solidFill>
+                  <a:srgbClr val="2E5A88"/>
+                </a:solidFill>
+                <a:latin typeface="Arial"/>
+              </a:rPr>
+              <a:t>ПОДГОТОВКА К ИГРЕ</a:t>
+            </a:r>
+          </a:p>
+        </p:txBody>
+      </p:sp>
+      <p:sp>
+        <p:nvSpPr>
+          <p:cNvPr id="14" name="TextBox 13"/>
+          <p:cNvSpPr txBox="1"/>
+          <p:nvPr/>
+        </p:nvSpPr>
+        <p:spPr>
+          <a:xfrm>
+            <a:off x="432000" y="4777079"/>
+            <a:ext cx="6696000" cy="786960"/>
+          </a:xfrm>
+          <a:prstGeom prst="rect">
+            <a:avLst/>
+          </a:prstGeom>
+          <a:noFill/>
+        </p:spPr>
+        <p:txBody>
+          <a:bodyPr wrap="square" anchor="t" lIns="0" rIns="0" tIns="0" bIns="0">
+            <a:spAutoFit/>
+          </a:bodyPr>
+          <a:lstStyle/>
+          <a:p>
+            <a:pPr>
+              <a:spcBef>
+                <a:spcPts val="0"/>
+              </a:spcBef>
+              <a:spcAft>
+                <a:spcPts val="200"/>
+              </a:spcAft>
+            </a:pPr>
+            <a:r>
+              <a:rPr sz="1100" b="0" i="0">
+                <a:solidFill>
+                  <a:srgbClr val="1A1A1A"/>
+                </a:solidFill>
+                <a:latin typeface="Arial"/>
+              </a:rPr>
+              <a:t>1. Перемешайте колоду карт запросов и положите её рубашками вверх. Верхняя карта колоды запросов показывает окончание будущего запроса на своей рубашке.</a:t>
+            </a:r>
+          </a:p>
+          <a:p>
+            <a:pPr>
+              <a:spcBef>
+                <a:spcPts val="0"/>
+              </a:spcBef>
+              <a:spcAft>
+                <a:spcPts val="200"/>
+              </a:spcAft>
+            </a:pPr>
+            <a:r>
+              <a:rPr sz="1100" b="0" i="0">
+                <a:solidFill>
+                  <a:srgbClr val="1A1A1A"/>
+                </a:solidFill>
+                <a:latin typeface="Arial"/>
+              </a:rPr>
+              <a:t>2. Каждый игрок выбирает цвет и берёт карту «Ты восхитителен» своего цвета. Лишние карты «Ты восхитителен» уберите в коробку.</a:t>
+            </a:r>
+          </a:p>
+          <a:p>
+            <a:pPr>
+              <a:spcBef>
+                <a:spcPts val="0"/>
+              </a:spcBef>
+              <a:spcAft>
+                <a:spcPts val="200"/>
+              </a:spcAft>
+            </a:pPr>
+            <a:r>
+              <a:rPr sz="1100" b="0" i="0">
+                <a:solidFill>
+                  <a:srgbClr val="1A1A1A"/>
+                </a:solidFill>
+                <a:latin typeface="Arial"/>
+              </a:rPr>
+              <a:t>3. Все карты букв раскиньте в случайном порядке лицом вверх в центре стола. Руки игроков в начале раунда пустые.</a:t>
             </a:r>
           </a:p>
         </p:txBody>
       </p:sp>
       <p:pic>
         <p:nvPicPr>
-          <p:cNvPr id="14" name="Picture 13" descr="card-letter-joker.png"/>
+          <p:cNvPr id="15" name="Picture 14" descr="setup-table.png"/>
           <p:cNvPicPr>
             <a:picLocks noChangeAspect="1"/>
           </p:cNvPicPr>
@@ -3759,297 +3611,8 @@
         </p:blipFill>
         <p:spPr>
           <a:xfrm>
-            <a:off x="4500000" y="5637600"/>
-            <a:ext cx="1224000" cy="945942"/>
-          </a:xfrm>
-          <a:prstGeom prst="rect">
-            <a:avLst/>
-          </a:prstGeom>
-        </p:spPr>
-      </p:pic>
-      <p:sp>
-        <p:nvSpPr>
-          <p:cNvPr id="15" name="TextBox 14"/>
-          <p:cNvSpPr txBox="1"/>
-          <p:nvPr/>
-        </p:nvSpPr>
-        <p:spPr>
-          <a:xfrm>
-            <a:off x="4500000" y="6602589"/>
-            <a:ext cx="1224000" cy="360000"/>
-          </a:xfrm>
-          <a:prstGeom prst="rect">
-            <a:avLst/>
-          </a:prstGeom>
-          <a:noFill/>
-        </p:spPr>
-        <p:txBody>
-          <a:bodyPr wrap="square" anchor="t" lIns="0" rIns="0" tIns="0" bIns="0">
-            <a:spAutoFit/>
-          </a:bodyPr>
-          <a:lstStyle/>
-          <a:p>
-            <a:pPr algn="ctr"/>
-            <a:r>
-              <a:rPr sz="800" b="0">
-                <a:solidFill>
-                  <a:srgbClr val="555555"/>
-                </a:solidFill>
-                <a:latin typeface="Arial"/>
-              </a:rPr>
-              <a:t>джокер</a:t>
-            </a:r>
-          </a:p>
-        </p:txBody>
-      </p:sp>
-      <p:pic>
-        <p:nvPicPr>
-          <p:cNvPr id="16" name="Picture 15" descr="card-vote.png"/>
-          <p:cNvPicPr>
-            <a:picLocks noChangeAspect="1"/>
-          </p:cNvPicPr>
-          <p:nvPr/>
-        </p:nvPicPr>
-        <p:blipFill>
-          <a:blip r:embed="rId6"/>
-          <a:stretch>
-            <a:fillRect/>
-          </a:stretch>
-        </p:blipFill>
-        <p:spPr>
-          <a:xfrm>
-            <a:off x="5832000" y="5637600"/>
-            <a:ext cx="1224000" cy="945942"/>
-          </a:xfrm>
-          <a:prstGeom prst="rect">
-            <a:avLst/>
-          </a:prstGeom>
-        </p:spPr>
-      </p:pic>
-      <p:sp>
-        <p:nvSpPr>
-          <p:cNvPr id="17" name="TextBox 16"/>
-          <p:cNvSpPr txBox="1"/>
-          <p:nvPr/>
-        </p:nvSpPr>
-        <p:spPr>
-          <a:xfrm>
-            <a:off x="5832000" y="6602589"/>
-            <a:ext cx="1224000" cy="360000"/>
-          </a:xfrm>
-          <a:prstGeom prst="rect">
-            <a:avLst/>
-          </a:prstGeom>
-          <a:noFill/>
-        </p:spPr>
-        <p:txBody>
-          <a:bodyPr wrap="square" anchor="t" lIns="0" rIns="0" tIns="0" bIns="0">
-            <a:spAutoFit/>
-          </a:bodyPr>
-          <a:lstStyle/>
-          <a:p>
-            <a:pPr algn="ctr"/>
-            <a:r>
-              <a:rPr sz="800" b="0">
-                <a:solidFill>
-                  <a:srgbClr val="555555"/>
-                </a:solidFill>
-                <a:latin typeface="Arial"/>
-              </a:rPr>
-              <a:t>«Ты восхитителен»</a:t>
-            </a:r>
-          </a:p>
-        </p:txBody>
-      </p:sp>
-      <p:sp>
-        <p:nvSpPr>
-          <p:cNvPr id="18" name="TextBox 17"/>
-          <p:cNvSpPr txBox="1"/>
-          <p:nvPr/>
-        </p:nvSpPr>
-        <p:spPr>
-          <a:xfrm>
-            <a:off x="432000" y="7016589"/>
-            <a:ext cx="6696000" cy="288000"/>
-          </a:xfrm>
-          <a:prstGeom prst="rect">
-            <a:avLst/>
-          </a:prstGeom>
-          <a:noFill/>
-        </p:spPr>
-        <p:txBody>
-          <a:bodyPr wrap="square" anchor="t" lIns="0" rIns="0" tIns="0" bIns="0">
-            <a:spAutoFit/>
-          </a:bodyPr>
-          <a:lstStyle/>
-          <a:p>
-            <a:r>
-              <a:rPr sz="1200" b="1">
-                <a:solidFill>
-                  <a:srgbClr val="2E5A88"/>
-                </a:solidFill>
-                <a:latin typeface="Arial"/>
-              </a:rPr>
-              <a:t>ПОДГОТОВКА К ИГРЕ</a:t>
-            </a:r>
-          </a:p>
-        </p:txBody>
-      </p:sp>
-      <p:sp>
-        <p:nvSpPr>
-          <p:cNvPr id="19" name="TextBox 18"/>
-          <p:cNvSpPr txBox="1"/>
-          <p:nvPr/>
-        </p:nvSpPr>
-        <p:spPr>
-          <a:xfrm>
-            <a:off x="432000" y="7304589"/>
-            <a:ext cx="6696000" cy="1501920"/>
-          </a:xfrm>
-          <a:prstGeom prst="rect">
-            <a:avLst/>
-          </a:prstGeom>
-          <a:noFill/>
-        </p:spPr>
-        <p:txBody>
-          <a:bodyPr wrap="square" anchor="t" lIns="0" rIns="0" tIns="0" bIns="0">
-            <a:spAutoFit/>
-          </a:bodyPr>
-          <a:lstStyle/>
-          <a:p>
-            <a:pPr>
-              <a:spcBef>
-                <a:spcPts val="0"/>
-              </a:spcBef>
-              <a:spcAft>
-                <a:spcPts val="200"/>
-              </a:spcAft>
-            </a:pPr>
-            <a:r>
-              <a:rPr sz="1100" b="0">
-                <a:solidFill>
-                  <a:srgbClr val="1A1A1A"/>
-                </a:solidFill>
-                <a:latin typeface="Arial"/>
-              </a:rPr>
-              <a:t>1. Перемешайте колоду запросов и положите её рубашками вверх.</a:t>
-            </a:r>
-          </a:p>
-          <a:p>
-            <a:pPr>
-              <a:spcBef>
-                <a:spcPts val="0"/>
-              </a:spcBef>
-              <a:spcAft>
-                <a:spcPts val="200"/>
-              </a:spcAft>
-            </a:pPr>
-            <a:r>
-              <a:rPr sz="1100" b="0">
-                <a:solidFill>
-                  <a:srgbClr val="1A1A1A"/>
-                </a:solidFill>
-                <a:latin typeface="Arial"/>
-              </a:rPr>
-              <a:t>   Верхняя карта показывает вторую половину будущего запроса.</a:t>
-            </a:r>
-          </a:p>
-          <a:p>
-            <a:pPr>
-              <a:spcBef>
-                <a:spcPts val="0"/>
-              </a:spcBef>
-              <a:spcAft>
-                <a:spcPts val="200"/>
-              </a:spcAft>
-            </a:pPr>
-            <a:r>
-              <a:rPr sz="1100" b="0">
-                <a:solidFill>
-                  <a:srgbClr val="1A1A1A"/>
-                </a:solidFill>
-                <a:latin typeface="Arial"/>
-              </a:rPr>
-              <a:t>2. Каждый игрок выбирает цвет и берёт карту «Ты восхитителен»</a:t>
-            </a:r>
-          </a:p>
-          <a:p>
-            <a:pPr>
-              <a:spcBef>
-                <a:spcPts val="0"/>
-              </a:spcBef>
-              <a:spcAft>
-                <a:spcPts val="200"/>
-              </a:spcAft>
-            </a:pPr>
-            <a:r>
-              <a:rPr sz="1100" b="0">
-                <a:solidFill>
-                  <a:srgbClr val="1A1A1A"/>
-                </a:solidFill>
-                <a:latin typeface="Arial"/>
-              </a:rPr>
-              <a:t>   своего цвета. Лишние уберите в коробку.</a:t>
-            </a:r>
-          </a:p>
-          <a:p>
-            <a:pPr>
-              <a:spcBef>
-                <a:spcPts val="0"/>
-              </a:spcBef>
-              <a:spcAft>
-                <a:spcPts val="200"/>
-              </a:spcAft>
-            </a:pPr>
-            <a:r>
-              <a:rPr sz="1100" b="0">
-                <a:solidFill>
-                  <a:srgbClr val="1A1A1A"/>
-                </a:solidFill>
-                <a:latin typeface="Arial"/>
-              </a:rPr>
-              <a:t>3. Раскиньте все карты букв лицом вверх в случайном порядке</a:t>
-            </a:r>
-          </a:p>
-          <a:p>
-            <a:pPr>
-              <a:spcBef>
-                <a:spcPts val="0"/>
-              </a:spcBef>
-              <a:spcAft>
-                <a:spcPts val="200"/>
-              </a:spcAft>
-            </a:pPr>
-            <a:r>
-              <a:rPr sz="1100" b="0">
-                <a:solidFill>
-                  <a:srgbClr val="1A1A1A"/>
-                </a:solidFill>
-                <a:latin typeface="Arial"/>
-              </a:rPr>
-              <a:t>   в центре стола. Руки игроков в начале раунда пустые.</a:t>
-            </a:r>
-          </a:p>
-        </p:txBody>
-      </p:sp>
-      <p:pic>
-        <p:nvPicPr>
-          <p:cNvPr id="20" name="Picture 19" descr="setup-table.png"/>
-          <p:cNvPicPr>
-            <a:picLocks noChangeAspect="1"/>
-          </p:cNvPicPr>
-          <p:nvPr/>
-        </p:nvPicPr>
-        <p:blipFill>
-          <a:blip r:embed="rId7"/>
-          <a:stretch>
-            <a:fillRect/>
-          </a:stretch>
-        </p:blipFill>
-        <p:spPr>
-          <a:xfrm>
-            <a:off x="2670659" y="8842509"/>
-            <a:ext cx="2218680" cy="1417012"/>
+            <a:off x="432000" y="5600039"/>
+            <a:ext cx="6696000" cy="4351975"/>
           </a:xfrm>
           <a:prstGeom prst="rect">
             <a:avLst/>
@@ -4097,7 +3660,7 @@
           <a:lstStyle/>
           <a:p>
             <a:r>
-              <a:rPr sz="1200" b="1">
+              <a:rPr sz="1200" b="1" i="0">
                 <a:solidFill>
                   <a:srgbClr val="2E5A88"/>
                 </a:solidFill>
@@ -4117,7 +3680,7 @@
         <p:spPr>
           <a:xfrm>
             <a:off x="432000" y="720000"/>
-            <a:ext cx="6696000" cy="786960"/>
+            <a:ext cx="6696000" cy="310320"/>
           </a:xfrm>
           <a:prstGeom prst="rect">
             <a:avLst/>
@@ -4139,15 +3702,72 @@
               </a:spcAft>
             </a:pPr>
             <a:r>
-              <a:rPr sz="1100" b="0">
+              <a:rPr sz="1100" b="0" i="0">
                 <a:solidFill>
                   <a:srgbClr val="1A1A1A"/>
                 </a:solidFill>
                 <a:latin typeface="Arial"/>
               </a:rPr>
-              <a:t>Набирайте карты запросов как победные очки. Когда колода</a:t>
-            </a:r>
-          </a:p>
+              <a:t>Набирайте карты запросов как победные очки. Когда колода запросов больше не позволяет начать раунд, побеждает игрок с наибольшим числом таких карт.</a:t>
+            </a:r>
+          </a:p>
+        </p:txBody>
+      </p:sp>
+      <p:sp>
+        <p:nvSpPr>
+          <p:cNvPr id="4" name="TextBox 3"/>
+          <p:cNvSpPr txBox="1"/>
+          <p:nvPr/>
+        </p:nvSpPr>
+        <p:spPr>
+          <a:xfrm>
+            <a:off x="432000" y="1066320"/>
+            <a:ext cx="6696000" cy="288000"/>
+          </a:xfrm>
+          <a:prstGeom prst="rect">
+            <a:avLst/>
+          </a:prstGeom>
+          <a:noFill/>
+        </p:spPr>
+        <p:txBody>
+          <a:bodyPr wrap="square" anchor="t" lIns="0" rIns="0" tIns="0" bIns="0">
+            <a:spAutoFit/>
+          </a:bodyPr>
+          <a:lstStyle/>
+          <a:p>
+            <a:r>
+              <a:rPr sz="1200" b="1" i="0">
+                <a:solidFill>
+                  <a:srgbClr val="2E5A88"/>
+                </a:solidFill>
+                <a:latin typeface="Arial"/>
+              </a:rPr>
+              <a:t>КАК УСТРОЕНА КАРТА ЗАПРОСА</a:t>
+            </a:r>
+          </a:p>
+        </p:txBody>
+      </p:sp>
+      <p:sp>
+        <p:nvSpPr>
+          <p:cNvPr id="5" name="TextBox 4"/>
+          <p:cNvSpPr txBox="1"/>
+          <p:nvPr/>
+        </p:nvSpPr>
+        <p:spPr>
+          <a:xfrm>
+            <a:off x="432000" y="1354320"/>
+            <a:ext cx="4644000" cy="2744519"/>
+          </a:xfrm>
+          <a:prstGeom prst="rect">
+            <a:avLst/>
+          </a:prstGeom>
+          <a:noFill/>
+        </p:spPr>
+        <p:txBody>
+          <a:bodyPr wrap="square" anchor="t" lIns="0" rIns="0" tIns="0" bIns="0">
+            <a:spAutoFit/>
+          </a:bodyPr>
+          <a:lstStyle/>
           <a:p>
             <a:pPr>
               <a:spcBef>
@@ -4158,13 +3778,13 @@
               </a:spcAft>
             </a:pPr>
             <a:r>
-              <a:rPr sz="1100" b="0">
+              <a:rPr sz="1000" b="0" i="0">
                 <a:solidFill>
                   <a:srgbClr val="1A1A1A"/>
                 </a:solidFill>
                 <a:latin typeface="Arial"/>
               </a:rPr>
-              <a:t>запросов больше не позволяет начать раунд, побеждает игрок</a:t>
+              <a:t>У каждой карты запроса две стороны.</a:t>
             </a:r>
           </a:p>
           <a:p>
@@ -4177,72 +3797,15 @@
               </a:spcAft>
             </a:pPr>
             <a:r>
-              <a:rPr sz="1100" b="0">
+              <a:rPr sz="1000" b="0" i="0">
                 <a:solidFill>
                   <a:srgbClr val="1A1A1A"/>
                 </a:solidFill>
                 <a:latin typeface="Arial"/>
               </a:rPr>
-              <a:t>с наибольшим числом таких карт.</a:t>
-            </a:r>
-          </a:p>
-        </p:txBody>
-      </p:sp>
-      <p:sp>
-        <p:nvSpPr>
-          <p:cNvPr id="4" name="TextBox 3"/>
-          <p:cNvSpPr txBox="1"/>
-          <p:nvPr/>
-        </p:nvSpPr>
-        <p:spPr>
-          <a:xfrm>
-            <a:off x="432000" y="1542960"/>
-            <a:ext cx="6696000" cy="288000"/>
-          </a:xfrm>
-          <a:prstGeom prst="rect">
-            <a:avLst/>
-          </a:prstGeom>
-          <a:noFill/>
-        </p:spPr>
-        <p:txBody>
-          <a:bodyPr wrap="square" anchor="t" lIns="0" rIns="0" tIns="0" bIns="0">
-            <a:spAutoFit/>
-          </a:bodyPr>
-          <a:lstStyle/>
-          <a:p>
-            <a:r>
-              <a:rPr sz="1200" b="1">
-                <a:solidFill>
-                  <a:srgbClr val="2E5A88"/>
-                </a:solidFill>
-                <a:latin typeface="Arial"/>
-              </a:rPr>
-              <a:t>КАК УСТРОЕНА КАРТА ЗАПРОСА</a:t>
-            </a:r>
-          </a:p>
-        </p:txBody>
-      </p:sp>
-      <p:sp>
-        <p:nvSpPr>
-          <p:cNvPr id="5" name="TextBox 4"/>
-          <p:cNvSpPr txBox="1"/>
-          <p:nvPr/>
-        </p:nvSpPr>
-        <p:spPr>
-          <a:xfrm>
-            <a:off x="432000" y="1830960"/>
-            <a:ext cx="6696000" cy="1025280"/>
-          </a:xfrm>
-          <a:prstGeom prst="rect">
-            <a:avLst/>
-          </a:prstGeom>
-          <a:noFill/>
-        </p:spPr>
-        <p:txBody>
-          <a:bodyPr wrap="square" anchor="t" lIns="0" rIns="0" tIns="0" bIns="0">
-            <a:spAutoFit/>
-          </a:bodyPr>
-          <a:lstStyle/>
+              <a:t>1. Лицевая сторона – начало фразы-запроса.</a:t>
+            </a:r>
+          </a:p>
           <a:p>
             <a:pPr>
               <a:spcBef>
@@ -4253,13 +3816,13 @@
               </a:spcAft>
             </a:pPr>
             <a:r>
-              <a:rPr sz="1100" b="0">
+              <a:rPr sz="1000" b="0" i="0">
                 <a:solidFill>
                   <a:srgbClr val="1A1A1A"/>
                 </a:solidFill>
                 <a:latin typeface="Arial"/>
               </a:rPr>
-              <a:t>1. Лицевая сторона – начало фразы-запроса.</a:t>
+              <a:t>2. Рубашка – окончание фразы-запроса.</a:t>
             </a:r>
           </a:p>
           <a:p>
@@ -4272,13 +3835,13 @@
               </a:spcAft>
             </a:pPr>
             <a:r>
-              <a:rPr sz="1100" b="0">
+              <a:rPr sz="1000" b="0" i="0">
                 <a:solidFill>
                   <a:srgbClr val="1A1A1A"/>
                 </a:solidFill>
                 <a:latin typeface="Arial"/>
               </a:rPr>
-              <a:t>2. Рубашка – окончание фразы-запроса.</a:t>
+              <a:t>Рамка зеркала на всех картах запросов одинаковая: при любой перетасовке лицевая сторона одной карты запроса и рубашка следующей сверху карты в колоде всегда складываются в одно изображение зеркала с целым текстом запроса.</a:t>
             </a:r>
           </a:p>
           <a:p>
@@ -4291,39 +3854,20 @@
               </a:spcAft>
             </a:pPr>
             <a:r>
-              <a:rPr sz="1100" b="0">
+              <a:rPr sz="1000" b="0" i="0">
                 <a:solidFill>
                   <a:srgbClr val="1A1A1A"/>
                 </a:solidFill>
                 <a:latin typeface="Arial"/>
               </a:rPr>
-              <a:t>Рамка зеркала на всех картах одинаковая: лицевая одной карты</a:t>
-            </a:r>
-          </a:p>
-          <a:p>
-            <a:pPr>
-              <a:spcBef>
-                <a:spcPts val="0"/>
-              </a:spcBef>
-              <a:spcAft>
-                <a:spcPts val="200"/>
-              </a:spcAft>
-            </a:pPr>
-            <a:r>
-              <a:rPr sz="1100" b="0">
-                <a:solidFill>
-                  <a:srgbClr val="1A1A1A"/>
-                </a:solidFill>
-                <a:latin typeface="Arial"/>
-              </a:rPr>
-              <a:t>и рубашка следующей сверху в колоде складываются в целый запрос.</a:t>
+              <a:t>Читаете вслух, например: «Расскажи чем испугать всех соседей сверху».</a:t>
             </a:r>
           </a:p>
         </p:txBody>
       </p:sp>
       <p:pic>
         <p:nvPicPr>
-          <p:cNvPr id="6" name="Picture 5" descr="card-request-face.png"/>
+          <p:cNvPr id="6" name="Picture 5" descr="card-request-pair.png"/>
           <p:cNvPicPr>
             <a:picLocks noChangeAspect="1"/>
           </p:cNvPicPr>
@@ -4337,8 +3881,8 @@
         </p:blipFill>
         <p:spPr>
           <a:xfrm>
-            <a:off x="1116000" y="2892240"/>
-            <a:ext cx="2520000" cy="1947528"/>
+            <a:off x="5256000" y="1354320"/>
+            <a:ext cx="1872000" cy="2744519"/>
           </a:xfrm>
           <a:prstGeom prst="rect">
             <a:avLst/>
@@ -4353,8 +3897,8 @@
         </p:nvSpPr>
         <p:spPr>
           <a:xfrm>
-            <a:off x="1116000" y="4859924"/>
-            <a:ext cx="2520000" cy="360000"/>
+            <a:off x="5256000" y="4109639"/>
+            <a:ext cx="1872000" cy="288000"/>
           </a:xfrm>
           <a:prstGeom prst="rect">
             <a:avLst/>
@@ -4369,51 +3913,27 @@
           <a:p>
             <a:pPr algn="ctr"/>
             <a:r>
-              <a:rPr sz="800" b="0">
+              <a:rPr sz="800" b="0" i="0">
                 <a:solidFill>
                   <a:srgbClr val="555555"/>
                 </a:solidFill>
                 <a:latin typeface="Arial"/>
               </a:rPr>
-              <a:t>«Расскажи чем испугать всех»</a:t>
-            </a:r>
-          </a:p>
-        </p:txBody>
-      </p:sp>
-      <p:pic>
-        <p:nvPicPr>
-          <p:cNvPr id="8" name="Picture 7" descr="card-request-back.png"/>
-          <p:cNvPicPr>
-            <a:picLocks noChangeAspect="1"/>
-          </p:cNvPicPr>
-          <p:nvPr/>
-        </p:nvPicPr>
-        <p:blipFill>
-          <a:blip r:embed="rId3"/>
-          <a:stretch>
-            <a:fillRect/>
-          </a:stretch>
-        </p:blipFill>
-        <p:spPr>
-          <a:xfrm>
-            <a:off x="3924000" y="2892240"/>
-            <a:ext cx="2520000" cy="1947528"/>
-          </a:xfrm>
-          <a:prstGeom prst="rect">
-            <a:avLst/>
-          </a:prstGeom>
-        </p:spPr>
-      </p:pic>
-      <p:sp>
-        <p:nvSpPr>
-          <p:cNvPr id="9" name="TextBox 8"/>
+              <a:t>лицевая сторона сверху, рубашка снизу</a:t>
+            </a:r>
+          </a:p>
+        </p:txBody>
+      </p:sp>
+      <p:sp>
+        <p:nvSpPr>
+          <p:cNvPr id="8" name="TextBox 7"/>
           <p:cNvSpPr txBox="1"/>
           <p:nvPr/>
         </p:nvSpPr>
         <p:spPr>
           <a:xfrm>
-            <a:off x="3924000" y="4859924"/>
-            <a:ext cx="2520000" cy="360000"/>
+            <a:off x="432000" y="4458839"/>
+            <a:ext cx="6696000" cy="288000"/>
           </a:xfrm>
           <a:prstGeom prst="rect">
             <a:avLst/>
@@ -4426,28 +3946,27 @@
           </a:bodyPr>
           <a:lstStyle/>
           <a:p>
-            <a:pPr algn="ctr"/>
-            <a:r>
-              <a:rPr sz="800" b="0">
-                <a:solidFill>
-                  <a:srgbClr val="555555"/>
-                </a:solidFill>
-                <a:latin typeface="Arial"/>
-              </a:rPr>
-              <a:t>«соседей сверху»</a:t>
-            </a:r>
-          </a:p>
-        </p:txBody>
-      </p:sp>
-      <p:sp>
-        <p:nvSpPr>
-          <p:cNvPr id="10" name="TextBox 9"/>
+            <a:r>
+              <a:rPr sz="1200" b="1" i="0">
+                <a:solidFill>
+                  <a:srgbClr val="2E5A88"/>
+                </a:solidFill>
+                <a:latin typeface="Arial"/>
+              </a:rPr>
+              <a:t>ХОД ИГРЫ</a:t>
+            </a:r>
+          </a:p>
+        </p:txBody>
+      </p:sp>
+      <p:sp>
+        <p:nvSpPr>
+          <p:cNvPr id="9" name="TextBox 8"/>
           <p:cNvSpPr txBox="1"/>
           <p:nvPr/>
         </p:nvSpPr>
         <p:spPr>
           <a:xfrm>
-            <a:off x="432000" y="5273924"/>
+            <a:off x="432000" y="4746839"/>
             <a:ext cx="6696000" cy="310320"/>
           </a:xfrm>
           <a:prstGeom prst="rect">
@@ -4470,121 +3989,26 @@
               </a:spcAft>
             </a:pPr>
             <a:r>
-              <a:rPr sz="1100" b="0">
+              <a:rPr sz="1100" b="0" i="0">
                 <a:solidFill>
                   <a:srgbClr val="1A1A1A"/>
                 </a:solidFill>
                 <a:latin typeface="Arial"/>
               </a:rPr>
-              <a:t>Читаете вслух: «Расскажи чем испугать всех соседей сверху».</a:t>
-            </a:r>
-          </a:p>
-        </p:txBody>
-      </p:sp>
-      <p:sp>
-        <p:nvSpPr>
-          <p:cNvPr id="11" name="TextBox 10"/>
-          <p:cNvSpPr txBox="1"/>
-          <p:nvPr/>
-        </p:nvSpPr>
-        <p:spPr>
-          <a:xfrm>
-            <a:off x="432000" y="5620244"/>
-            <a:ext cx="6696000" cy="288000"/>
-          </a:xfrm>
-          <a:prstGeom prst="rect">
-            <a:avLst/>
-          </a:prstGeom>
-          <a:noFill/>
-        </p:spPr>
-        <p:txBody>
-          <a:bodyPr wrap="square" anchor="t" lIns="0" rIns="0" tIns="0" bIns="0">
-            <a:spAutoFit/>
-          </a:bodyPr>
-          <a:lstStyle/>
-          <a:p>
-            <a:r>
-              <a:rPr sz="1200" b="1">
-                <a:solidFill>
-                  <a:srgbClr val="2E5A88"/>
-                </a:solidFill>
-                <a:latin typeface="Arial"/>
-              </a:rPr>
-              <a:t>ХОД ИГРЫ</a:t>
-            </a:r>
-          </a:p>
-        </p:txBody>
-      </p:sp>
-      <p:sp>
-        <p:nvSpPr>
-          <p:cNvPr id="12" name="TextBox 11"/>
-          <p:cNvSpPr txBox="1"/>
-          <p:nvPr/>
-        </p:nvSpPr>
-        <p:spPr>
-          <a:xfrm>
-            <a:off x="432000" y="5908244"/>
-            <a:ext cx="6696000" cy="548640"/>
-          </a:xfrm>
-          <a:prstGeom prst="rect">
-            <a:avLst/>
-          </a:prstGeom>
-          <a:noFill/>
-        </p:spPr>
-        <p:txBody>
-          <a:bodyPr wrap="square" anchor="t" lIns="0" rIns="0" tIns="0" bIns="0">
-            <a:spAutoFit/>
-          </a:bodyPr>
-          <a:lstStyle/>
-          <a:p>
-            <a:pPr>
-              <a:spcBef>
-                <a:spcPts val="0"/>
-              </a:spcBef>
-              <a:spcAft>
-                <a:spcPts val="200"/>
-              </a:spcAft>
-            </a:pPr>
-            <a:r>
-              <a:rPr sz="1100" b="0">
-                <a:solidFill>
-                  <a:srgbClr val="1A1A1A"/>
-                </a:solidFill>
-                <a:latin typeface="Arial"/>
-              </a:rPr>
-              <a:t>Игра идёт раундами. Все действия в раунде, кроме возврата карт</a:t>
-            </a:r>
-          </a:p>
-          <a:p>
-            <a:pPr>
-              <a:spcBef>
-                <a:spcPts val="0"/>
-              </a:spcBef>
-              <a:spcAft>
-                <a:spcPts val="200"/>
-              </a:spcAft>
-            </a:pPr>
-            <a:r>
-              <a:rPr sz="1100" b="0">
-                <a:solidFill>
-                  <a:srgbClr val="1A1A1A"/>
-                </a:solidFill>
-                <a:latin typeface="Arial"/>
-              </a:rPr>
-              <a:t>букв в центр, выполняются одновременно, если не сказано иное.</a:t>
-            </a:r>
-          </a:p>
-        </p:txBody>
-      </p:sp>
-      <p:sp>
-        <p:nvSpPr>
-          <p:cNvPr id="13" name="Rounded Rectangle 12"/>
+              <a:t>Игра идёт раундами. Все действия в раунде выполняются одновременно.</a:t>
+            </a:r>
+          </a:p>
+        </p:txBody>
+      </p:sp>
+      <p:sp>
+        <p:nvSpPr>
+          <p:cNvPr id="10" name="Rounded Rectangle 9"/>
           <p:cNvSpPr/>
           <p:nvPr/>
         </p:nvSpPr>
         <p:spPr>
           <a:xfrm>
-            <a:off x="432000" y="6492884"/>
+            <a:off x="432000" y="5093159"/>
             <a:ext cx="1566000" cy="792000"/>
           </a:xfrm>
           <a:prstGeom prst="roundRect">
@@ -4620,7 +4044,7 @@
           <a:p>
             <a:pPr algn="ctr"/>
             <a:r>
-              <a:rPr sz="900" b="1">
+              <a:rPr sz="900" b="1" i="0">
                 <a:solidFill>
                   <a:srgbClr val="1A1A1A"/>
                 </a:solidFill>
@@ -4633,13 +4057,13 @@
       </p:sp>
       <p:sp>
         <p:nvSpPr>
-          <p:cNvPr id="14" name="Rounded Rectangle 13"/>
+          <p:cNvPr id="11" name="Rounded Rectangle 10"/>
           <p:cNvSpPr/>
           <p:nvPr/>
         </p:nvSpPr>
         <p:spPr>
           <a:xfrm>
-            <a:off x="2142000" y="6492884"/>
+            <a:off x="2142000" y="5093159"/>
             <a:ext cx="1566000" cy="792000"/>
           </a:xfrm>
           <a:prstGeom prst="roundRect">
@@ -4675,7 +4099,7 @@
           <a:p>
             <a:pPr algn="ctr"/>
             <a:r>
-              <a:rPr sz="900" b="1">
+              <a:rPr sz="900" b="1" i="0">
                 <a:solidFill>
                   <a:srgbClr val="1A1A1A"/>
                 </a:solidFill>
@@ -4688,13 +4112,13 @@
       </p:sp>
       <p:sp>
         <p:nvSpPr>
-          <p:cNvPr id="15" name="Rounded Rectangle 14"/>
+          <p:cNvPr id="12" name="Rounded Rectangle 11"/>
           <p:cNvSpPr/>
           <p:nvPr/>
         </p:nvSpPr>
         <p:spPr>
           <a:xfrm>
-            <a:off x="3852000" y="6492884"/>
+            <a:off x="3852000" y="5093159"/>
             <a:ext cx="1566000" cy="792000"/>
           </a:xfrm>
           <a:prstGeom prst="roundRect">
@@ -4730,7 +4154,7 @@
           <a:p>
             <a:pPr algn="ctr"/>
             <a:r>
-              <a:rPr sz="900" b="1">
+              <a:rPr sz="900" b="1" i="0">
                 <a:solidFill>
                   <a:srgbClr val="1A1A1A"/>
                 </a:solidFill>
@@ -4743,13 +4167,13 @@
       </p:sp>
       <p:sp>
         <p:nvSpPr>
-          <p:cNvPr id="16" name="Rounded Rectangle 15"/>
+          <p:cNvPr id="13" name="Rounded Rectangle 12"/>
           <p:cNvSpPr/>
           <p:nvPr/>
         </p:nvSpPr>
         <p:spPr>
           <a:xfrm>
-            <a:off x="5562000" y="6492884"/>
+            <a:off x="5562000" y="5093159"/>
             <a:ext cx="1566000" cy="792000"/>
           </a:xfrm>
           <a:prstGeom prst="roundRect">
@@ -4785,7 +4209,7 @@
           <a:p>
             <a:pPr algn="ctr"/>
             <a:r>
-              <a:rPr sz="900" b="1">
+              <a:rPr sz="900" b="1" i="0">
                 <a:solidFill>
                   <a:srgbClr val="1A1A1A"/>
                 </a:solidFill>
@@ -4798,14 +4222,14 @@
       </p:sp>
       <p:sp>
         <p:nvSpPr>
-          <p:cNvPr id="17" name="TextBox 16"/>
+          <p:cNvPr id="14" name="TextBox 13"/>
           <p:cNvSpPr txBox="1"/>
           <p:nvPr/>
         </p:nvSpPr>
         <p:spPr>
           <a:xfrm>
-            <a:off x="432000" y="7392884"/>
-            <a:ext cx="6696000" cy="2527200"/>
+            <a:off x="432000" y="5993159"/>
+            <a:ext cx="6696000" cy="1857600"/>
           </a:xfrm>
           <a:prstGeom prst="rect">
             <a:avLst/>
@@ -4827,13 +4251,13 @@
               </a:spcAft>
             </a:pPr>
             <a:r>
-              <a:rPr sz="1000" b="0">
+              <a:rPr sz="1000" b="0" i="0">
                 <a:solidFill>
                   <a:srgbClr val="1A1A1A"/>
                 </a:solidFill>
                 <a:latin typeface="Arial"/>
               </a:rPr>
-              <a:t>1. Снимите верхнюю карту, переверните на лицевую рядом с колодой.</a:t>
+              <a:t>1. Снимите верхнюю карту колоды запросов, переверните её на лицевую сторону и положите рядом с колодой так, чтобы вместе с новой верхней картой колоды запросов (с её рубашкой) получилось общее зеркало.</a:t>
             </a:r>
           </a:p>
           <a:p>
@@ -4846,13 +4270,13 @@
               </a:spcAft>
             </a:pPr>
             <a:r>
-              <a:rPr sz="1000" b="0">
+              <a:rPr sz="1000" b="0" i="0">
                 <a:solidFill>
                   <a:srgbClr val="1A1A1A"/>
                 </a:solidFill>
                 <a:latin typeface="Arial"/>
               </a:rPr>
-              <a:t>   Прочитайте: лицевая + рубашка новой верхней карты.</a:t>
+              <a:t>Прочитайте вслух текст на лицевой стороне открытой карты запроса и на рубашке верхней карты запроса.</a:t>
             </a:r>
           </a:p>
           <a:p>
@@ -4865,13 +4289,13 @@
               </a:spcAft>
             </a:pPr>
             <a:r>
-              <a:rPr sz="1000" b="0">
+              <a:rPr sz="1000" b="0" i="0">
                 <a:solidFill>
                   <a:srgbClr val="1A1A1A"/>
                 </a:solidFill>
                 <a:latin typeface="Arial"/>
               </a:rPr>
-              <a:t>   Если пары нет – конец игры.</a:t>
+              <a:t>Если карты кончились, наступает конец игры.</a:t>
             </a:r>
           </a:p>
           <a:p>
@@ -4884,13 +4308,13 @@
               </a:spcAft>
             </a:pPr>
             <a:r>
-              <a:rPr sz="1000" b="0">
+              <a:rPr sz="1000" b="0" i="0">
                 <a:solidFill>
                   <a:srgbClr val="1A1A1A"/>
                 </a:solidFill>
                 <a:latin typeface="Arial"/>
               </a:rPr>
-              <a:t>2. Игроки одновременно берут буквы из центра одной рукой по 1 карте.</a:t>
+              <a:t>2. Игроки одновременно берут карты букв из центра стола одной рукой по одной карте. Второй рукой можно держать взятое, но не копаться в куче.</a:t>
             </a:r>
           </a:p>
           <a:p>
@@ -4903,13 +4327,13 @@
               </a:spcAft>
             </a:pPr>
             <a:r>
-              <a:rPr sz="1000" b="0">
+              <a:rPr sz="1000" b="0" i="0">
                 <a:solidFill>
                   <a:srgbClr val="1A1A1A"/>
                 </a:solidFill>
                 <a:latin typeface="Arial"/>
               </a:rPr>
-              <a:t>   Второй рукой можно держать взятое; копаться в куче нельзя.</a:t>
+              <a:t>Берите карты букв, пока вам хватит на ответ. Лишние карты букв остаются в центре стола.</a:t>
             </a:r>
           </a:p>
           <a:p>
@@ -4922,13 +4346,13 @@
               </a:spcAft>
             </a:pPr>
             <a:r>
-              <a:rPr sz="1000" b="0">
+              <a:rPr sz="1000" b="0" i="0">
                 <a:solidFill>
                   <a:srgbClr val="1A1A1A"/>
                 </a:solidFill>
                 <a:latin typeface="Arial"/>
               </a:rPr>
-              <a:t>   Берите, пока хватит на ответ. Лишнее остаётся в центре.</a:t>
+              <a:t>Любую карту буквы можно сыграть рубашкой вверх как джокер (любая буква). Замену вслух не называйте.</a:t>
             </a:r>
           </a:p>
           <a:p>
@@ -4941,13 +4365,13 @@
               </a:spcAft>
             </a:pPr>
             <a:r>
-              <a:rPr sz="1000" b="0">
+              <a:rPr sz="1000" b="0" i="0">
                 <a:solidFill>
                   <a:srgbClr val="1A1A1A"/>
                 </a:solidFill>
                 <a:latin typeface="Arial"/>
               </a:rPr>
-              <a:t>   Рубашка буквы вверх = джокер (замену вслух не называете).</a:t>
+              <a:t>3. Голосование – см. ниже.</a:t>
             </a:r>
           </a:p>
           <a:p>
@@ -4960,15 +4384,72 @@
               </a:spcAft>
             </a:pPr>
             <a:r>
-              <a:rPr sz="1000" b="0">
+              <a:rPr sz="1000" b="0" i="0">
                 <a:solidFill>
                   <a:srgbClr val="1A1A1A"/>
                 </a:solidFill>
                 <a:latin typeface="Arial"/>
               </a:rPr>
-              <a:t>3. Все одновременно кидают «Ты восхитителен» к другому игроку.</a:t>
-            </a:r>
-          </a:p>
+              <a:t>4. Все карты букв возвращаются в центр стола, перемешиваются и снова раскидываются лицом вверх.</a:t>
+            </a:r>
+          </a:p>
+        </p:txBody>
+      </p:sp>
+      <p:sp>
+        <p:nvSpPr>
+          <p:cNvPr id="15" name="TextBox 14"/>
+          <p:cNvSpPr txBox="1"/>
+          <p:nvPr/>
+        </p:nvSpPr>
+        <p:spPr>
+          <a:xfrm>
+            <a:off x="432000" y="7886759"/>
+            <a:ext cx="6696000" cy="288000"/>
+          </a:xfrm>
+          <a:prstGeom prst="rect">
+            <a:avLst/>
+          </a:prstGeom>
+          <a:noFill/>
+        </p:spPr>
+        <p:txBody>
+          <a:bodyPr wrap="square" anchor="t" lIns="0" rIns="0" tIns="0" bIns="0">
+            <a:spAutoFit/>
+          </a:bodyPr>
+          <a:lstStyle/>
+          <a:p>
+            <a:r>
+              <a:rPr sz="1200" b="1" i="0">
+                <a:solidFill>
+                  <a:srgbClr val="2E5A88"/>
+                </a:solidFill>
+                <a:latin typeface="Arial"/>
+              </a:rPr>
+              <a:t>СОСТАВЛЕНИЕ ОТВЕТА</a:t>
+            </a:r>
+          </a:p>
+        </p:txBody>
+      </p:sp>
+      <p:sp>
+        <p:nvSpPr>
+          <p:cNvPr id="16" name="TextBox 15"/>
+          <p:cNvSpPr txBox="1"/>
+          <p:nvPr/>
+        </p:nvSpPr>
+        <p:spPr>
+          <a:xfrm>
+            <a:off x="2844000" y="8174759"/>
+            <a:ext cx="4284000" cy="1140581"/>
+          </a:xfrm>
+          <a:prstGeom prst="rect">
+            <a:avLst/>
+          </a:prstGeom>
+          <a:noFill/>
+        </p:spPr>
+        <p:txBody>
+          <a:bodyPr wrap="square" anchor="t" lIns="0" rIns="0" tIns="0" bIns="0">
+            <a:spAutoFit/>
+          </a:bodyPr>
+          <a:lstStyle/>
           <a:p>
             <a:pPr>
               <a:spcBef>
@@ -4979,13 +4460,13 @@
               </a:spcAft>
             </a:pPr>
             <a:r>
-              <a:rPr sz="1000" b="0">
+              <a:rPr sz="1000" b="0" i="0">
                 <a:solidFill>
                   <a:srgbClr val="1A1A1A"/>
                 </a:solidFill>
                 <a:latin typeface="Arial"/>
               </a:rPr>
-              <a:t>   Победитель раунда забирает лицевую карту запроса.</a:t>
+              <a:t>Ответ – слово или фраза на усмотрение игрока в пределах взятых карт букв. Допустимы несуществующие и неполные слова.</a:t>
             </a:r>
           </a:p>
           <a:p>
@@ -4998,13 +4479,13 @@
               </a:spcAft>
             </a:pPr>
             <a:r>
-              <a:rPr sz="1000" b="0">
+              <a:rPr sz="1000" b="0" i="0">
                 <a:solidFill>
                   <a:srgbClr val="1A1A1A"/>
                 </a:solidFill>
                 <a:latin typeface="Arial"/>
               </a:rPr>
-              <a:t>4. Все карты букв возвращаются в центр, перемешиваются</a:t>
+              <a:t>Несыгранные взятые карты букв остаются у игрока до конца раунда.</a:t>
             </a:r>
           </a:p>
           <a:p>
@@ -5017,13 +4498,114 @@
               </a:spcAft>
             </a:pPr>
             <a:r>
-              <a:rPr sz="1000" b="0">
+              <a:rPr sz="1000" b="0" i="0">
                 <a:solidFill>
                   <a:srgbClr val="1A1A1A"/>
                 </a:solidFill>
                 <a:latin typeface="Arial"/>
               </a:rPr>
-              <a:t>   и снова раскидываются лицом вверх.</a:t>
+              <a:t>Игрок выкладывает свой ответ перед собой на стол, когда готов.</a:t>
+            </a:r>
+          </a:p>
+        </p:txBody>
+      </p:sp>
+      <p:pic>
+        <p:nvPicPr>
+          <p:cNvPr id="17" name="Picture 16" descr="card-letter-duplex.png"/>
+          <p:cNvPicPr>
+            <a:picLocks noChangeAspect="1"/>
+          </p:cNvPicPr>
+          <p:nvPr/>
+        </p:nvPicPr>
+        <p:blipFill>
+          <a:blip r:embed="rId3"/>
+          <a:stretch>
+            <a:fillRect/>
+          </a:stretch>
+        </p:blipFill>
+        <p:spPr>
+          <a:xfrm>
+            <a:off x="432000" y="8174759"/>
+            <a:ext cx="2232000" cy="1140581"/>
+          </a:xfrm>
+          <a:prstGeom prst="rect">
+            <a:avLst/>
+          </a:prstGeom>
+        </p:spPr>
+      </p:pic>
+      <p:sp>
+        <p:nvSpPr>
+          <p:cNvPr id="18" name="TextBox 17"/>
+          <p:cNvSpPr txBox="1"/>
+          <p:nvPr/>
+        </p:nvSpPr>
+        <p:spPr>
+          <a:xfrm>
+            <a:off x="432000" y="9326140"/>
+            <a:ext cx="2232000" cy="288000"/>
+          </a:xfrm>
+          <a:prstGeom prst="rect">
+            <a:avLst/>
+          </a:prstGeom>
+          <a:noFill/>
+        </p:spPr>
+        <p:txBody>
+          <a:bodyPr wrap="square" anchor="t" lIns="0" rIns="0" tIns="0" bIns="0">
+            <a:spAutoFit/>
+          </a:bodyPr>
+          <a:lstStyle/>
+          <a:p>
+            <a:pPr algn="ctr"/>
+            <a:r>
+              <a:rPr sz="800" b="0" i="0">
+                <a:solidFill>
+                  <a:srgbClr val="555555"/>
+                </a:solidFill>
+                <a:latin typeface="Arial"/>
+              </a:rPr>
+              <a:t>карты букв: лицо и рубашка-джокер</a:t>
+            </a:r>
+          </a:p>
+        </p:txBody>
+      </p:sp>
+      <p:sp>
+        <p:nvSpPr>
+          <p:cNvPr id="19" name="TextBox 18"/>
+          <p:cNvSpPr txBox="1"/>
+          <p:nvPr/>
+        </p:nvSpPr>
+        <p:spPr>
+          <a:xfrm>
+            <a:off x="432000" y="9675340"/>
+            <a:ext cx="6696000" cy="310320"/>
+          </a:xfrm>
+          <a:prstGeom prst="rect">
+            <a:avLst/>
+          </a:prstGeom>
+          <a:noFill/>
+        </p:spPr>
+        <p:txBody>
+          <a:bodyPr wrap="square" anchor="t" lIns="0" rIns="0" tIns="0" bIns="0">
+            <a:spAutoFit/>
+          </a:bodyPr>
+          <a:lstStyle/>
+          <a:p>
+            <a:pPr>
+              <a:spcBef>
+                <a:spcPts val="0"/>
+              </a:spcBef>
+              <a:spcAft>
+                <a:spcPts val="200"/>
+              </a:spcAft>
+            </a:pPr>
+            <a:r>
+              <a:rPr sz="1100" b="0" i="1">
+                <a:solidFill>
+                  <a:srgbClr val="1A1A1A"/>
+                </a:solidFill>
+                <a:latin typeface="Arial"/>
+              </a:rPr>
+              <a:t>Пример: запрос «Чем соблазнить милф». Настя выложила «БЕЗ ТРУСОВ» (позже получит 3 голоса), Артём – «В ПОДЪЕЗДЕ» (1 голос), Кирилл – «МАМИН ДРУГ» (0 голосов).</a:t>
             </a:r>
           </a:p>
         </p:txBody>
@@ -5069,13 +4651,13 @@
           <a:lstStyle/>
           <a:p>
             <a:r>
-              <a:rPr sz="1200" b="1">
+              <a:rPr sz="1200" b="1" i="0">
                 <a:solidFill>
                   <a:srgbClr val="2E5A88"/>
                 </a:solidFill>
                 <a:latin typeface="Arial"/>
               </a:rPr>
-              <a:t>СОСТАВЛЕНИЕ ОТВЕТА</a:t>
+              <a:t>ГОЛОСОВАНИЕ</a:t>
             </a:r>
           </a:p>
         </p:txBody>
@@ -5089,7 +4671,7 @@
         <p:spPr>
           <a:xfrm>
             <a:off x="432000" y="720000"/>
-            <a:ext cx="6696000" cy="786960"/>
+            <a:ext cx="4788000" cy="1454400"/>
           </a:xfrm>
           <a:prstGeom prst="rect">
             <a:avLst/>
@@ -5111,13 +4693,13 @@
               </a:spcAft>
             </a:pPr>
             <a:r>
-              <a:rPr sz="1100" b="0">
+              <a:rPr sz="1000" b="0" i="0">
                 <a:solidFill>
                   <a:srgbClr val="1A1A1A"/>
                 </a:solidFill>
                 <a:latin typeface="Arial"/>
               </a:rPr>
-              <a:t>Ответ – слово или фраза на усмотрение игрока. Допустимы</a:t>
+              <a:t>Каждый игрок берёт в руку карту голосования. Когда все определились с выбором, то по команде одновременно кидают на понравившееся слово (если очень хочется – можно в составившего его игрока). Если неясно, к кому упала – кинувший поясняет.</a:t>
             </a:r>
           </a:p>
           <a:p>
@@ -5130,13 +4712,13 @@
               </a:spcAft>
             </a:pPr>
             <a:r>
-              <a:rPr sz="1100" b="0">
+              <a:rPr sz="1000" b="0" i="0">
                 <a:solidFill>
                   <a:srgbClr val="1A1A1A"/>
                 </a:solidFill>
                 <a:latin typeface="Arial"/>
               </a:rPr>
-              <a:t>несуществующие и неполные слова. Несыгранные взятые буквы</a:t>
+              <a:t>Себе карту голосования оставлять нельзя: кидайте только к чужому ответу.</a:t>
             </a:r>
           </a:p>
           <a:p>
@@ -5149,20 +4731,77 @@
               </a:spcAft>
             </a:pPr>
             <a:r>
-              <a:rPr sz="1100" b="0">
+              <a:rPr sz="1000" b="0" i="0">
                 <a:solidFill>
                   <a:srgbClr val="1A1A1A"/>
                 </a:solidFill>
                 <a:latin typeface="Arial"/>
               </a:rPr>
-              <a:t>остаются у игрока до конца раунда.</a:t>
+              <a:t>Если игрок не успел кинуть карту голосования вместе с остальными, его карта не учитывается, а каждый другой игрок получает по 2 голоса.</a:t>
+            </a:r>
+          </a:p>
+          <a:p>
+            <a:pPr>
+              <a:spcBef>
+                <a:spcPts val="0"/>
+              </a:spcBef>
+              <a:spcAft>
+                <a:spcPts val="200"/>
+              </a:spcAft>
+            </a:pPr>
+            <a:r>
+              <a:rPr sz="1000" b="0" i="0">
+                <a:solidFill>
+                  <a:srgbClr val="1A1A1A"/>
+                </a:solidFill>
+                <a:latin typeface="Arial"/>
+              </a:rPr>
+              <a:t>Победитель раунда – игрок, перед которым оказалось больше всего карт голосования. Он берёт карту запроса, лежащую лицевой стороной вверх, и кладёт её перед собой как победное очко.</a:t>
+            </a:r>
+          </a:p>
+          <a:p>
+            <a:pPr>
+              <a:spcBef>
+                <a:spcPts val="0"/>
+              </a:spcBef>
+              <a:spcAft>
+                <a:spcPts val="200"/>
+              </a:spcAft>
+            </a:pPr>
+            <a:r>
+              <a:rPr sz="1000" b="0" i="0">
+                <a:solidFill>
+                  <a:srgbClr val="1A1A1A"/>
+                </a:solidFill>
+                <a:latin typeface="Arial"/>
+              </a:rPr>
+              <a:t>Ничья по голосам. Если лидеров несколько, все они объявляются победителями раунда. Один из них берёт лицевую карту запроса, остальные по очереди (по часовой стрелке от обладателя лицевой карты запроса или по договорённости) берут по одной карте с верха колоды запросов как победные очки. Часть будущих запросов при этом выбывает – так и задумано.</a:t>
+            </a:r>
+          </a:p>
+          <a:p>
+            <a:pPr>
+              <a:spcBef>
+                <a:spcPts val="0"/>
+              </a:spcBef>
+              <a:spcAft>
+                <a:spcPts val="200"/>
+              </a:spcAft>
+            </a:pPr>
+            <a:r>
+              <a:rPr sz="1000" b="0" i="0">
+                <a:solidFill>
+                  <a:srgbClr val="1A1A1A"/>
+                </a:solidFill>
+                <a:latin typeface="Arial"/>
+              </a:rPr>
+              <a:t>После определения победителя или победителей верните карты «Ты восхитителен» владельцам в руку – они снова понадобятся в следующем раунде.</a:t>
             </a:r>
           </a:p>
         </p:txBody>
       </p:sp>
       <p:pic>
         <p:nvPicPr>
-          <p:cNvPr id="4" name="Picture 3" descr="card-letter.png"/>
+          <p:cNvPr id="4" name="Picture 3" descr="card-vote-stack.png"/>
           <p:cNvPicPr>
             <a:picLocks noChangeAspect="1"/>
           </p:cNvPicPr>
@@ -5176,8 +4815,8 @@
         </p:blipFill>
         <p:spPr>
           <a:xfrm>
-            <a:off x="1872000" y="1542960"/>
-            <a:ext cx="1728000" cy="1335448"/>
+            <a:off x="5400000" y="720000"/>
+            <a:ext cx="1728000" cy="1236706"/>
           </a:xfrm>
           <a:prstGeom prst="rect">
             <a:avLst/>
@@ -5192,7 +4831,7 @@
         </p:nvSpPr>
         <p:spPr>
           <a:xfrm>
-            <a:off x="1872000" y="2897886"/>
+            <a:off x="5400000" y="1967505"/>
             <a:ext cx="1728000" cy="288000"/>
           </a:xfrm>
           <a:prstGeom prst="rect">
@@ -5208,20 +4847,594 @@
           <a:p>
             <a:pPr algn="ctr"/>
             <a:r>
-              <a:rPr sz="800" b="0">
+              <a:rPr sz="800" b="0" i="0">
                 <a:solidFill>
                   <a:srgbClr val="555555"/>
                 </a:solidFill>
                 <a:latin typeface="Arial"/>
               </a:rPr>
-              <a:t>буква лицом</a:t>
+              <a:t>карты голосования «Ты восхитителен»</a:t>
+            </a:r>
+          </a:p>
+        </p:txBody>
+      </p:sp>
+      <p:sp>
+        <p:nvSpPr>
+          <p:cNvPr id="6" name="TextBox 5"/>
+          <p:cNvSpPr txBox="1"/>
+          <p:nvPr/>
+        </p:nvSpPr>
+        <p:spPr>
+          <a:xfrm>
+            <a:off x="432000" y="2316705"/>
+            <a:ext cx="6696000" cy="288000"/>
+          </a:xfrm>
+          <a:prstGeom prst="rect">
+            <a:avLst/>
+          </a:prstGeom>
+          <a:noFill/>
+        </p:spPr>
+        <p:txBody>
+          <a:bodyPr wrap="square" anchor="t" lIns="0" rIns="0" tIns="0" bIns="0">
+            <a:spAutoFit/>
+          </a:bodyPr>
+          <a:lstStyle/>
+          <a:p>
+            <a:r>
+              <a:rPr sz="1200" b="1" i="0">
+                <a:solidFill>
+                  <a:srgbClr val="2E5A88"/>
+                </a:solidFill>
+                <a:latin typeface="Arial"/>
+              </a:rPr>
+              <a:t>КОНЕЦ ИГРЫ</a:t>
+            </a:r>
+          </a:p>
+        </p:txBody>
+      </p:sp>
+      <p:sp>
+        <p:nvSpPr>
+          <p:cNvPr id="7" name="TextBox 6"/>
+          <p:cNvSpPr txBox="1"/>
+          <p:nvPr/>
+        </p:nvSpPr>
+        <p:spPr>
+          <a:xfrm>
+            <a:off x="432000" y="2604705"/>
+            <a:ext cx="6696000" cy="1025280"/>
+          </a:xfrm>
+          <a:prstGeom prst="rect">
+            <a:avLst/>
+          </a:prstGeom>
+          <a:noFill/>
+        </p:spPr>
+        <p:txBody>
+          <a:bodyPr wrap="square" anchor="t" lIns="0" rIns="0" tIns="0" bIns="0">
+            <a:spAutoFit/>
+          </a:bodyPr>
+          <a:lstStyle/>
+          <a:p>
+            <a:pPr>
+              <a:spcBef>
+                <a:spcPts val="0"/>
+              </a:spcBef>
+              <a:spcAft>
+                <a:spcPts val="200"/>
+              </a:spcAft>
+            </a:pPr>
+            <a:r>
+              <a:rPr sz="1100" b="0" i="0">
+                <a:solidFill>
+                  <a:srgbClr val="1A1A1A"/>
+                </a:solidFill>
+                <a:latin typeface="Arial"/>
+              </a:rPr>
+              <a:t>Игра заканчивается, когда колода запросов больше не позволяет начать раунд: карты кончились или осталась одна карта запроса без пары для зеркала.</a:t>
+            </a:r>
+          </a:p>
+          <a:p>
+            <a:pPr>
+              <a:spcBef>
+                <a:spcPts val="0"/>
+              </a:spcBef>
+              <a:spcAft>
+                <a:spcPts val="200"/>
+              </a:spcAft>
+            </a:pPr>
+            <a:r>
+              <a:rPr sz="1100" b="0" i="0">
+                <a:solidFill>
+                  <a:srgbClr val="1A1A1A"/>
+                </a:solidFill>
+                <a:latin typeface="Arial"/>
+              </a:rPr>
+              <a:t>1. Каждый игрок считает карты запросов, лежащие перед ним как победные очки.</a:t>
+            </a:r>
+          </a:p>
+          <a:p>
+            <a:pPr>
+              <a:spcBef>
+                <a:spcPts val="0"/>
+              </a:spcBef>
+              <a:spcAft>
+                <a:spcPts val="200"/>
+              </a:spcAft>
+            </a:pPr>
+            <a:r>
+              <a:rPr sz="1100" b="0" i="0">
+                <a:solidFill>
+                  <a:srgbClr val="1A1A1A"/>
+                </a:solidFill>
+                <a:latin typeface="Arial"/>
+              </a:rPr>
+              <a:t>2. Побеждает игрок с наибольшим числом таких карт.</a:t>
+            </a:r>
+          </a:p>
+          <a:p>
+            <a:pPr>
+              <a:spcBef>
+                <a:spcPts val="0"/>
+              </a:spcBef>
+              <a:spcAft>
+                <a:spcPts val="200"/>
+              </a:spcAft>
+            </a:pPr>
+            <a:r>
+              <a:rPr sz="1100" b="0" i="0">
+                <a:solidFill>
+                  <a:srgbClr val="1A1A1A"/>
+                </a:solidFill>
+                <a:latin typeface="Arial"/>
+              </a:rPr>
+              <a:t>При ничьей объявите совместную победу.</a:t>
+            </a:r>
+          </a:p>
+        </p:txBody>
+      </p:sp>
+      <p:sp>
+        <p:nvSpPr>
+          <p:cNvPr id="8" name="TextBox 7"/>
+          <p:cNvSpPr txBox="1"/>
+          <p:nvPr/>
+        </p:nvSpPr>
+        <p:spPr>
+          <a:xfrm>
+            <a:off x="432000" y="3665985"/>
+            <a:ext cx="6696000" cy="288000"/>
+          </a:xfrm>
+          <a:prstGeom prst="rect">
+            <a:avLst/>
+          </a:prstGeom>
+          <a:noFill/>
+        </p:spPr>
+        <p:txBody>
+          <a:bodyPr wrap="square" anchor="t" lIns="0" rIns="0" tIns="0" bIns="0">
+            <a:spAutoFit/>
+          </a:bodyPr>
+          <a:lstStyle/>
+          <a:p>
+            <a:r>
+              <a:rPr sz="1200" b="1" i="0">
+                <a:solidFill>
+                  <a:srgbClr val="2E5A88"/>
+                </a:solidFill>
+                <a:latin typeface="Arial"/>
+              </a:rPr>
+              <a:t>ЧАСТЫЕ ВОПРОСЫ</a:t>
+            </a:r>
+          </a:p>
+        </p:txBody>
+      </p:sp>
+      <p:sp>
+        <p:nvSpPr>
+          <p:cNvPr id="9" name="TextBox 8"/>
+          <p:cNvSpPr txBox="1"/>
+          <p:nvPr/>
+        </p:nvSpPr>
+        <p:spPr>
+          <a:xfrm>
+            <a:off x="432000" y="3953985"/>
+            <a:ext cx="6696000" cy="1188000"/>
+          </a:xfrm>
+          <a:prstGeom prst="rect">
+            <a:avLst/>
+          </a:prstGeom>
+          <a:noFill/>
+        </p:spPr>
+        <p:txBody>
+          <a:bodyPr wrap="square" anchor="t" lIns="0" rIns="0" tIns="0" bIns="0">
+            <a:spAutoFit/>
+          </a:bodyPr>
+          <a:lstStyle/>
+          <a:p>
+            <a:pPr>
+              <a:spcBef>
+                <a:spcPts val="0"/>
+              </a:spcBef>
+              <a:spcAft>
+                <a:spcPts val="200"/>
+              </a:spcAft>
+            </a:pPr>
+            <a:r>
+              <a:rPr sz="1000" b="0" i="0">
+                <a:solidFill>
+                  <a:srgbClr val="1A1A1A"/>
+                </a:solidFill>
+                <a:latin typeface="Arial"/>
+              </a:rPr>
+              <a:t>? Можно ли кинуть карту голосования себе?  Нет. Только к чужому ответу.</a:t>
+            </a:r>
+          </a:p>
+          <a:p>
+            <a:pPr>
+              <a:spcBef>
+                <a:spcPts val="0"/>
+              </a:spcBef>
+              <a:spcAft>
+                <a:spcPts val="200"/>
+              </a:spcAft>
+            </a:pPr>
+            <a:r>
+              <a:rPr sz="1000" b="0" i="0">
+                <a:solidFill>
+                  <a:srgbClr val="1A1A1A"/>
+                </a:solidFill>
+                <a:latin typeface="Arial"/>
+              </a:rPr>
+              <a:t>? Карта голосования упала между двумя игроками – чей это голос?  Кинувший поясняет.</a:t>
+            </a:r>
+          </a:p>
+          <a:p>
+            <a:pPr>
+              <a:spcBef>
+                <a:spcPts val="0"/>
+              </a:spcBef>
+              <a:spcAft>
+                <a:spcPts val="200"/>
+              </a:spcAft>
+            </a:pPr>
+            <a:r>
+              <a:rPr sz="1000" b="0" i="0">
+                <a:solidFill>
+                  <a:srgbClr val="1A1A1A"/>
+                </a:solidFill>
+                <a:latin typeface="Arial"/>
+              </a:rPr>
+              <a:t>? Можно ли копаться в разложенных картах букв?  Нет. Берите только сверху или с края кучи, одной рукой по одной карте. Второй рукой можно держать взятое, но не копаться в куче.</a:t>
+            </a:r>
+          </a:p>
+          <a:p>
+            <a:pPr>
+              <a:spcBef>
+                <a:spcPts val="0"/>
+              </a:spcBef>
+              <a:spcAft>
+                <a:spcPts val="200"/>
+              </a:spcAft>
+            </a:pPr>
+            <a:r>
+              <a:rPr sz="1000" b="0" i="0">
+                <a:solidFill>
+                  <a:srgbClr val="1A1A1A"/>
+                </a:solidFill>
+                <a:latin typeface="Arial"/>
+              </a:rPr>
+              <a:t>? Когда переставать брать карты букв?  Когда вам хватит карт букв на ваш ответ.</a:t>
+            </a:r>
+          </a:p>
+          <a:p>
+            <a:pPr>
+              <a:spcBef>
+                <a:spcPts val="0"/>
+              </a:spcBef>
+              <a:spcAft>
+                <a:spcPts val="200"/>
+              </a:spcAft>
+            </a:pPr>
+            <a:r>
+              <a:rPr sz="1000" b="0" i="0">
+                <a:solidFill>
+                  <a:srgbClr val="1A1A1A"/>
+                </a:solidFill>
+                <a:latin typeface="Arial"/>
+              </a:rPr>
+              <a:t>? Сколько джокеров можно сыграть?  Сколько угодно. Зал реже голосует за нечитаемый ответ.</a:t>
+            </a:r>
+          </a:p>
+        </p:txBody>
+      </p:sp>
+      <p:sp>
+        <p:nvSpPr>
+          <p:cNvPr id="10" name="TextBox 9"/>
+          <p:cNvSpPr txBox="1"/>
+          <p:nvPr/>
+        </p:nvSpPr>
+        <p:spPr>
+          <a:xfrm>
+            <a:off x="432000" y="5177985"/>
+            <a:ext cx="6696000" cy="288000"/>
+          </a:xfrm>
+          <a:prstGeom prst="rect">
+            <a:avLst/>
+          </a:prstGeom>
+          <a:noFill/>
+        </p:spPr>
+        <p:txBody>
+          <a:bodyPr wrap="square" anchor="t" lIns="0" rIns="0" tIns="0" bIns="0">
+            <a:spAutoFit/>
+          </a:bodyPr>
+          <a:lstStyle/>
+          <a:p>
+            <a:r>
+              <a:rPr sz="1200" b="1" i="0">
+                <a:solidFill>
+                  <a:srgbClr val="2E5A88"/>
+                </a:solidFill>
+                <a:latin typeface="Arial"/>
+              </a:rPr>
+              <a:t>СОЗДАТЕЛИ</a:t>
+            </a:r>
+          </a:p>
+        </p:txBody>
+      </p:sp>
+      <p:sp>
+        <p:nvSpPr>
+          <p:cNvPr id="11" name="TextBox 10"/>
+          <p:cNvSpPr txBox="1"/>
+          <p:nvPr/>
+        </p:nvSpPr>
+        <p:spPr>
+          <a:xfrm>
+            <a:off x="432000" y="5465985"/>
+            <a:ext cx="6696000" cy="741600"/>
+          </a:xfrm>
+          <a:prstGeom prst="rect">
+            <a:avLst/>
+          </a:prstGeom>
+          <a:noFill/>
+        </p:spPr>
+        <p:txBody>
+          <a:bodyPr wrap="square" anchor="t" lIns="0" rIns="0" tIns="0" bIns="0">
+            <a:spAutoFit/>
+          </a:bodyPr>
+          <a:lstStyle/>
+          <a:p>
+            <a:pPr>
+              <a:spcBef>
+                <a:spcPts val="0"/>
+              </a:spcBef>
+              <a:spcAft>
+                <a:spcPts val="200"/>
+              </a:spcAft>
+            </a:pPr>
+            <a:r>
+              <a:rPr sz="1000" b="0" i="0">
+                <a:solidFill>
+                  <a:srgbClr val="1A1A1A"/>
+                </a:solidFill>
+                <a:latin typeface="Arial"/>
+              </a:rPr>
+              <a:t>Автор: Юрий Ямщиков</a:t>
+            </a:r>
+          </a:p>
+          <a:p>
+            <a:pPr>
+              <a:spcBef>
+                <a:spcPts val="0"/>
+              </a:spcBef>
+              <a:spcAft>
+                <a:spcPts val="200"/>
+              </a:spcAft>
+            </a:pPr>
+            <a:r>
+              <a:rPr sz="1000" b="0" i="0">
+                <a:solidFill>
+                  <a:srgbClr val="1A1A1A"/>
+                </a:solidFill>
+                <a:latin typeface="Arial"/>
+              </a:rPr>
+              <a:t>Редакция / развитие: [плейсхолдер]</a:t>
+            </a:r>
+          </a:p>
+          <a:p>
+            <a:pPr>
+              <a:spcBef>
+                <a:spcPts val="0"/>
+              </a:spcBef>
+              <a:spcAft>
+                <a:spcPts val="200"/>
+              </a:spcAft>
+            </a:pPr>
+            <a:r>
+              <a:rPr sz="1000" b="0" i="0">
+                <a:solidFill>
+                  <a:srgbClr val="1A1A1A"/>
+                </a:solidFill>
+                <a:latin typeface="Arial"/>
+              </a:rPr>
+              <a:t>Версия правил 3.7</a:t>
+            </a:r>
+          </a:p>
+        </p:txBody>
+      </p:sp>
+      <p:sp>
+        <p:nvSpPr>
+          <p:cNvPr id="12" name="TextBox 11"/>
+          <p:cNvSpPr txBox="1"/>
+          <p:nvPr/>
+        </p:nvSpPr>
+        <p:spPr>
+          <a:xfrm>
+            <a:off x="432000" y="6243585"/>
+            <a:ext cx="6696000" cy="288000"/>
+          </a:xfrm>
+          <a:prstGeom prst="rect">
+            <a:avLst/>
+          </a:prstGeom>
+          <a:noFill/>
+        </p:spPr>
+        <p:txBody>
+          <a:bodyPr wrap="square" anchor="t" lIns="0" rIns="0" tIns="0" bIns="0">
+            <a:spAutoFit/>
+          </a:bodyPr>
+          <a:lstStyle/>
+          <a:p>
+            <a:r>
+              <a:rPr sz="1200" b="1" i="0">
+                <a:solidFill>
+                  <a:srgbClr val="2E5A88"/>
+                </a:solidFill>
+                <a:latin typeface="Arial"/>
+              </a:rPr>
+              <a:t>ПАМЯТКА РАУНДА</a:t>
+            </a:r>
+          </a:p>
+        </p:txBody>
+      </p:sp>
+      <p:sp>
+        <p:nvSpPr>
+          <p:cNvPr id="13" name="TextBox 12"/>
+          <p:cNvSpPr txBox="1"/>
+          <p:nvPr/>
+        </p:nvSpPr>
+        <p:spPr>
+          <a:xfrm>
+            <a:off x="432000" y="6531585"/>
+            <a:ext cx="6696000" cy="1025280"/>
+          </a:xfrm>
+          <a:prstGeom prst="rect">
+            <a:avLst/>
+          </a:prstGeom>
+          <a:noFill/>
+        </p:spPr>
+        <p:txBody>
+          <a:bodyPr wrap="square" anchor="t" lIns="0" rIns="0" tIns="0" bIns="0">
+            <a:spAutoFit/>
+          </a:bodyPr>
+          <a:lstStyle/>
+          <a:p>
+            <a:pPr>
+              <a:spcBef>
+                <a:spcPts val="0"/>
+              </a:spcBef>
+              <a:spcAft>
+                <a:spcPts val="200"/>
+              </a:spcAft>
+            </a:pPr>
+            <a:r>
+              <a:rPr sz="1100" b="0" i="0">
+                <a:solidFill>
+                  <a:srgbClr val="1A1A1A"/>
+                </a:solidFill>
+                <a:latin typeface="Arial"/>
+              </a:rPr>
+              <a:t>1. Открыть карту запроса: снять верхнюю карту колоды запросов, перевернуть на лицевую сторону, прочитать текст на лицевой стороне открытой карты запроса и на рубашке верхней карты запроса.</a:t>
+            </a:r>
+          </a:p>
+          <a:p>
+            <a:pPr>
+              <a:spcBef>
+                <a:spcPts val="0"/>
+              </a:spcBef>
+              <a:spcAft>
+                <a:spcPts val="200"/>
+              </a:spcAft>
+            </a:pPr>
+            <a:r>
+              <a:rPr sz="1100" b="0" i="0">
+                <a:solidFill>
+                  <a:srgbClr val="1A1A1A"/>
+                </a:solidFill>
+                <a:latin typeface="Arial"/>
+              </a:rPr>
+              <a:t>2. Взять карты букв из центра стола (одна рука, по одной карте) и собрать ответ.</a:t>
+            </a:r>
+          </a:p>
+          <a:p>
+            <a:pPr>
+              <a:spcBef>
+                <a:spcPts val="0"/>
+              </a:spcBef>
+              <a:spcAft>
+                <a:spcPts val="200"/>
+              </a:spcAft>
+            </a:pPr>
+            <a:r>
+              <a:rPr sz="1100" b="0" i="0">
+                <a:solidFill>
+                  <a:srgbClr val="1A1A1A"/>
+                </a:solidFill>
+                <a:latin typeface="Arial"/>
+              </a:rPr>
+              <a:t>3. Кинуть карту голосования на понравившееся слово.</a:t>
+            </a:r>
+          </a:p>
+          <a:p>
+            <a:pPr>
+              <a:spcBef>
+                <a:spcPts val="0"/>
+              </a:spcBef>
+              <a:spcAft>
+                <a:spcPts val="200"/>
+              </a:spcAft>
+            </a:pPr>
+            <a:r>
+              <a:rPr sz="1100" b="0" i="0">
+                <a:solidFill>
+                  <a:srgbClr val="1A1A1A"/>
+                </a:solidFill>
+                <a:latin typeface="Arial"/>
+              </a:rPr>
+              <a:t>4. Все карты букв вернуть в центр стола, перемешать и раскидать лицом вверх.</a:t>
+            </a:r>
+          </a:p>
+        </p:txBody>
+      </p:sp>
+      <p:sp>
+        <p:nvSpPr>
+          <p:cNvPr id="14" name="TextBox 13"/>
+          <p:cNvSpPr txBox="1"/>
+          <p:nvPr/>
+        </p:nvSpPr>
+        <p:spPr>
+          <a:xfrm>
+            <a:off x="432000" y="7592865"/>
+            <a:ext cx="6696000" cy="310320"/>
+          </a:xfrm>
+          <a:prstGeom prst="rect">
+            <a:avLst/>
+          </a:prstGeom>
+          <a:noFill/>
+        </p:spPr>
+        <p:txBody>
+          <a:bodyPr wrap="square" anchor="t" lIns="0" rIns="0" tIns="0" bIns="0">
+            <a:spAutoFit/>
+          </a:bodyPr>
+          <a:lstStyle/>
+          <a:p>
+            <a:pPr>
+              <a:spcBef>
+                <a:spcPts val="0"/>
+              </a:spcBef>
+              <a:spcAft>
+                <a:spcPts val="200"/>
+              </a:spcAft>
+            </a:pPr>
+            <a:r>
+              <a:rPr sz="1100" b="0" i="0">
+                <a:solidFill>
+                  <a:srgbClr val="1A1A1A"/>
+                </a:solidFill>
+                <a:latin typeface="Arial"/>
+              </a:rPr>
+              <a:t>После раунда все карты букв снова лежат в центре стола лицом вверх.</a:t>
             </a:r>
           </a:p>
         </p:txBody>
       </p:sp>
       <p:pic>
         <p:nvPicPr>
-          <p:cNvPr id="6" name="Picture 5" descr="card-letter-joker.png"/>
+          <p:cNvPr id="15" name="Picture 14" descr="setup-table.png"/>
           <p:cNvPicPr>
             <a:picLocks noChangeAspect="1"/>
           </p:cNvPicPr>
@@ -5235,598 +5448,14 @@
         </p:blipFill>
         <p:spPr>
           <a:xfrm>
-            <a:off x="3960000" y="1542960"/>
-            <a:ext cx="1728000" cy="1335448"/>
+            <a:off x="1994758" y="7939185"/>
+            <a:ext cx="3570483" cy="2320587"/>
           </a:xfrm>
           <a:prstGeom prst="rect">
             <a:avLst/>
           </a:prstGeom>
         </p:spPr>
       </p:pic>
-      <p:sp>
-        <p:nvSpPr>
-          <p:cNvPr id="7" name="TextBox 6"/>
-          <p:cNvSpPr txBox="1"/>
-          <p:nvPr/>
-        </p:nvSpPr>
-        <p:spPr>
-          <a:xfrm>
-            <a:off x="3960000" y="2897886"/>
-            <a:ext cx="1728000" cy="288000"/>
-          </a:xfrm>
-          <a:prstGeom prst="rect">
-            <a:avLst/>
-          </a:prstGeom>
-          <a:noFill/>
-        </p:spPr>
-        <p:txBody>
-          <a:bodyPr wrap="square" anchor="t" lIns="0" rIns="0" tIns="0" bIns="0">
-            <a:spAutoFit/>
-          </a:bodyPr>
-          <a:lstStyle/>
-          <a:p>
-            <a:pPr algn="ctr"/>
-            <a:r>
-              <a:rPr sz="800" b="0">
-                <a:solidFill>
-                  <a:srgbClr val="555555"/>
-                </a:solidFill>
-                <a:latin typeface="Arial"/>
-              </a:rPr>
-              <a:t>рубашка = джокер</a:t>
-            </a:r>
-          </a:p>
-        </p:txBody>
-      </p:sp>
-      <p:sp>
-        <p:nvSpPr>
-          <p:cNvPr id="8" name="TextBox 7"/>
-          <p:cNvSpPr txBox="1"/>
-          <p:nvPr/>
-        </p:nvSpPr>
-        <p:spPr>
-          <a:xfrm>
-            <a:off x="432000" y="3239886"/>
-            <a:ext cx="6696000" cy="288000"/>
-          </a:xfrm>
-          <a:prstGeom prst="rect">
-            <a:avLst/>
-          </a:prstGeom>
-          <a:noFill/>
-        </p:spPr>
-        <p:txBody>
-          <a:bodyPr wrap="square" anchor="t" lIns="0" rIns="0" tIns="0" bIns="0">
-            <a:spAutoFit/>
-          </a:bodyPr>
-          <a:lstStyle/>
-          <a:p>
-            <a:r>
-              <a:rPr sz="1200" b="1">
-                <a:solidFill>
-                  <a:srgbClr val="2E5A88"/>
-                </a:solidFill>
-                <a:latin typeface="Arial"/>
-              </a:rPr>
-              <a:t>ГОЛОСОВАНИЕ «ТЫ ВОСХИТИТЕЛЕН»</a:t>
-            </a:r>
-          </a:p>
-        </p:txBody>
-      </p:sp>
-      <p:sp>
-        <p:nvSpPr>
-          <p:cNvPr id="9" name="TextBox 8"/>
-          <p:cNvSpPr txBox="1"/>
-          <p:nvPr/>
-        </p:nvSpPr>
-        <p:spPr>
-          <a:xfrm>
-            <a:off x="432000" y="3527886"/>
-            <a:ext cx="6696000" cy="1411200"/>
-          </a:xfrm>
-          <a:prstGeom prst="rect">
-            <a:avLst/>
-          </a:prstGeom>
-          <a:noFill/>
-        </p:spPr>
-        <p:txBody>
-          <a:bodyPr wrap="square" anchor="t" lIns="0" rIns="0" tIns="0" bIns="0">
-            <a:spAutoFit/>
-          </a:bodyPr>
-          <a:lstStyle/>
-          <a:p>
-            <a:pPr>
-              <a:spcBef>
-                <a:spcPts val="0"/>
-              </a:spcBef>
-              <a:spcAft>
-                <a:spcPts val="200"/>
-              </a:spcAft>
-            </a:pPr>
-            <a:r>
-              <a:rPr sz="1000" b="0">
-                <a:solidFill>
-                  <a:srgbClr val="1A1A1A"/>
-                </a:solidFill>
-                <a:latin typeface="Arial"/>
-              </a:rPr>
-              <a:t>Карта должна быть в руке. Все кидают одновременно к другому</a:t>
-            </a:r>
-          </a:p>
-          <a:p>
-            <a:pPr>
-              <a:spcBef>
-                <a:spcPts val="0"/>
-              </a:spcBef>
-              <a:spcAft>
-                <a:spcPts val="200"/>
-              </a:spcAft>
-            </a:pPr>
-            <a:r>
-              <a:rPr sz="1000" b="0">
-                <a:solidFill>
-                  <a:srgbClr val="1A1A1A"/>
-                </a:solidFill>
-                <a:latin typeface="Arial"/>
-              </a:rPr>
-              <a:t>игроку: себе оставлять нельзя. Неясно, к кому упала – решает</a:t>
-            </a:r>
-          </a:p>
-          <a:p>
-            <a:pPr>
-              <a:spcBef>
-                <a:spcPts val="0"/>
-              </a:spcBef>
-              <a:spcAft>
-                <a:spcPts val="200"/>
-              </a:spcAft>
-            </a:pPr>
-            <a:r>
-              <a:rPr sz="1000" b="0">
-                <a:solidFill>
-                  <a:srgbClr val="1A1A1A"/>
-                </a:solidFill>
-                <a:latin typeface="Arial"/>
-              </a:rPr>
-              <a:t>владелец карты словами. Опоздал кинуть: его карта не учитывается,</a:t>
-            </a:r>
-          </a:p>
-          <a:p>
-            <a:pPr>
-              <a:spcBef>
-                <a:spcPts val="0"/>
-              </a:spcBef>
-              <a:spcAft>
-                <a:spcPts val="200"/>
-              </a:spcAft>
-            </a:pPr>
-            <a:r>
-              <a:rPr sz="1000" b="0">
-                <a:solidFill>
-                  <a:srgbClr val="1A1A1A"/>
-                </a:solidFill>
-                <a:latin typeface="Arial"/>
-              </a:rPr>
-              <a:t>а каждый другой игрок получает по 2 голоса.</a:t>
-            </a:r>
-          </a:p>
-          <a:p>
-            <a:pPr>
-              <a:spcBef>
-                <a:spcPts val="0"/>
-              </a:spcBef>
-              <a:spcAft>
-                <a:spcPts val="200"/>
-              </a:spcAft>
-            </a:pPr>
-            <a:r>
-              <a:rPr sz="1000" b="0">
-                <a:solidFill>
-                  <a:srgbClr val="1A1A1A"/>
-                </a:solidFill>
-                <a:latin typeface="Arial"/>
-              </a:rPr>
-              <a:t>Ничья: все лидеры побеждают. Один берёт лицевую карту, остальные</a:t>
-            </a:r>
-          </a:p>
-          <a:p>
-            <a:pPr>
-              <a:spcBef>
-                <a:spcPts val="0"/>
-              </a:spcBef>
-              <a:spcAft>
-                <a:spcPts val="200"/>
-              </a:spcAft>
-            </a:pPr>
-            <a:r>
-              <a:rPr sz="1000" b="0">
-                <a:solidFill>
-                  <a:srgbClr val="1A1A1A"/>
-                </a:solidFill>
-                <a:latin typeface="Arial"/>
-              </a:rPr>
-              <a:t>по часовой стрелке – по карте с верха колоды запросов.</a:t>
-            </a:r>
-          </a:p>
-        </p:txBody>
-      </p:sp>
-      <p:sp>
-        <p:nvSpPr>
-          <p:cNvPr id="10" name="TextBox 9"/>
-          <p:cNvSpPr txBox="1"/>
-          <p:nvPr/>
-        </p:nvSpPr>
-        <p:spPr>
-          <a:xfrm>
-            <a:off x="432000" y="4975086"/>
-            <a:ext cx="6696000" cy="288000"/>
-          </a:xfrm>
-          <a:prstGeom prst="rect">
-            <a:avLst/>
-          </a:prstGeom>
-          <a:noFill/>
-        </p:spPr>
-        <p:txBody>
-          <a:bodyPr wrap="square" anchor="t" lIns="0" rIns="0" tIns="0" bIns="0">
-            <a:spAutoFit/>
-          </a:bodyPr>
-          <a:lstStyle/>
-          <a:p>
-            <a:r>
-              <a:rPr sz="1200" b="1">
-                <a:solidFill>
-                  <a:srgbClr val="2E5A88"/>
-                </a:solidFill>
-                <a:latin typeface="Arial"/>
-              </a:rPr>
-              <a:t>ПРИМЕР</a:t>
-            </a:r>
-          </a:p>
-        </p:txBody>
-      </p:sp>
-      <p:sp>
-        <p:nvSpPr>
-          <p:cNvPr id="11" name="TextBox 10"/>
-          <p:cNvSpPr txBox="1"/>
-          <p:nvPr/>
-        </p:nvSpPr>
-        <p:spPr>
-          <a:xfrm>
-            <a:off x="432000" y="5263086"/>
-            <a:ext cx="6696000" cy="964800"/>
-          </a:xfrm>
-          <a:prstGeom prst="rect">
-            <a:avLst/>
-          </a:prstGeom>
-          <a:noFill/>
-        </p:spPr>
-        <p:txBody>
-          <a:bodyPr wrap="square" anchor="t" lIns="0" rIns="0" tIns="0" bIns="0">
-            <a:spAutoFit/>
-          </a:bodyPr>
-          <a:lstStyle/>
-          <a:p>
-            <a:pPr>
-              <a:spcBef>
-                <a:spcPts val="0"/>
-              </a:spcBef>
-              <a:spcAft>
-                <a:spcPts val="200"/>
-              </a:spcAft>
-            </a:pPr>
-            <a:r>
-              <a:rPr sz="1000" b="0">
-                <a:solidFill>
-                  <a:srgbClr val="1A1A1A"/>
-                </a:solidFill>
-                <a:latin typeface="Arial"/>
-              </a:rPr>
-              <a:t>Запрос: «Чем соблазнить милф». Настя собрала ТИШИНА (3 голоса),</a:t>
-            </a:r>
-          </a:p>
-          <a:p>
-            <a:pPr>
-              <a:spcBef>
-                <a:spcPts val="0"/>
-              </a:spcBef>
-              <a:spcAft>
-                <a:spcPts val="200"/>
-              </a:spcAft>
-            </a:pPr>
-            <a:r>
-              <a:rPr sz="1000" b="0">
-                <a:solidFill>
-                  <a:srgbClr val="1A1A1A"/>
-                </a:solidFill>
-                <a:latin typeface="Arial"/>
-              </a:rPr>
-              <a:t>Артём – ШОКОЛАД (1), Кирилл – КОТЫ (0). Победитель – Настя:</a:t>
-            </a:r>
-          </a:p>
-          <a:p>
-            <a:pPr>
-              <a:spcBef>
-                <a:spcPts val="0"/>
-              </a:spcBef>
-              <a:spcAft>
-                <a:spcPts val="200"/>
-              </a:spcAft>
-            </a:pPr>
-            <a:r>
-              <a:rPr sz="1000" b="0">
-                <a:solidFill>
-                  <a:srgbClr val="1A1A1A"/>
-                </a:solidFill>
-                <a:latin typeface="Arial"/>
-              </a:rPr>
-              <a:t>она берёт лицевую карту запроса. Карты «Ты восхитителен»</a:t>
-            </a:r>
-          </a:p>
-          <a:p>
-            <a:pPr>
-              <a:spcBef>
-                <a:spcPts val="0"/>
-              </a:spcBef>
-              <a:spcAft>
-                <a:spcPts val="200"/>
-              </a:spcAft>
-            </a:pPr>
-            <a:r>
-              <a:rPr sz="1000" b="0">
-                <a:solidFill>
-                  <a:srgbClr val="1A1A1A"/>
-                </a:solidFill>
-                <a:latin typeface="Arial"/>
-              </a:rPr>
-              <a:t>возвращаются владельцам, все буквы – в центр стола.</a:t>
-            </a:r>
-          </a:p>
-        </p:txBody>
-      </p:sp>
-      <p:pic>
-        <p:nvPicPr>
-          <p:cNvPr id="12" name="Picture 11" descr="card-vote.png"/>
-          <p:cNvPicPr>
-            <a:picLocks noChangeAspect="1"/>
-          </p:cNvPicPr>
-          <p:nvPr/>
-        </p:nvPicPr>
-        <p:blipFill>
-          <a:blip r:embed="rId4"/>
-          <a:stretch>
-            <a:fillRect/>
-          </a:stretch>
-        </p:blipFill>
-        <p:spPr>
-          <a:xfrm>
-            <a:off x="2880000" y="6263886"/>
-            <a:ext cx="1800000" cy="1391091"/>
-          </a:xfrm>
-          <a:prstGeom prst="rect">
-            <a:avLst/>
-          </a:prstGeom>
-        </p:spPr>
-      </p:pic>
-      <p:sp>
-        <p:nvSpPr>
-          <p:cNvPr id="13" name="TextBox 12"/>
-          <p:cNvSpPr txBox="1"/>
-          <p:nvPr/>
-        </p:nvSpPr>
-        <p:spPr>
-          <a:xfrm>
-            <a:off x="2880000" y="7674517"/>
-            <a:ext cx="1800000" cy="288000"/>
-          </a:xfrm>
-          <a:prstGeom prst="rect">
-            <a:avLst/>
-          </a:prstGeom>
-          <a:noFill/>
-        </p:spPr>
-        <p:txBody>
-          <a:bodyPr wrap="square" anchor="t" lIns="0" rIns="0" tIns="0" bIns="0">
-            <a:spAutoFit/>
-          </a:bodyPr>
-          <a:lstStyle/>
-          <a:p>
-            <a:pPr algn="ctr"/>
-            <a:r>
-              <a:rPr sz="800" b="0">
-                <a:solidFill>
-                  <a:srgbClr val="555555"/>
-                </a:solidFill>
-                <a:latin typeface="Arial"/>
-              </a:rPr>
-              <a:t>голос (кидают к другому)</a:t>
-            </a:r>
-          </a:p>
-        </p:txBody>
-      </p:sp>
-      <p:sp>
-        <p:nvSpPr>
-          <p:cNvPr id="14" name="TextBox 13"/>
-          <p:cNvSpPr txBox="1"/>
-          <p:nvPr/>
-        </p:nvSpPr>
-        <p:spPr>
-          <a:xfrm>
-            <a:off x="432000" y="8016517"/>
-            <a:ext cx="6696000" cy="288000"/>
-          </a:xfrm>
-          <a:prstGeom prst="rect">
-            <a:avLst/>
-          </a:prstGeom>
-          <a:noFill/>
-        </p:spPr>
-        <p:txBody>
-          <a:bodyPr wrap="square" anchor="t" lIns="0" rIns="0" tIns="0" bIns="0">
-            <a:spAutoFit/>
-          </a:bodyPr>
-          <a:lstStyle/>
-          <a:p>
-            <a:r>
-              <a:rPr sz="1200" b="1">
-                <a:solidFill>
-                  <a:srgbClr val="2E5A88"/>
-                </a:solidFill>
-                <a:latin typeface="Arial"/>
-              </a:rPr>
-              <a:t>КОНЕЦ ИГРЫ</a:t>
-            </a:r>
-          </a:p>
-        </p:txBody>
-      </p:sp>
-      <p:sp>
-        <p:nvSpPr>
-          <p:cNvPr id="15" name="TextBox 14"/>
-          <p:cNvSpPr txBox="1"/>
-          <p:nvPr/>
-        </p:nvSpPr>
-        <p:spPr>
-          <a:xfrm>
-            <a:off x="432000" y="8304517"/>
-            <a:ext cx="6696000" cy="1263600"/>
-          </a:xfrm>
-          <a:prstGeom prst="rect">
-            <a:avLst/>
-          </a:prstGeom>
-          <a:noFill/>
-        </p:spPr>
-        <p:txBody>
-          <a:bodyPr wrap="square" anchor="t" lIns="0" rIns="0" tIns="0" bIns="0">
-            <a:spAutoFit/>
-          </a:bodyPr>
-          <a:lstStyle/>
-          <a:p>
-            <a:pPr>
-              <a:spcBef>
-                <a:spcPts val="0"/>
-              </a:spcBef>
-              <a:spcAft>
-                <a:spcPts val="200"/>
-              </a:spcAft>
-            </a:pPr>
-            <a:r>
-              <a:rPr sz="1100" b="0">
-                <a:solidFill>
-                  <a:srgbClr val="1A1A1A"/>
-                </a:solidFill>
-                <a:latin typeface="Arial"/>
-              </a:rPr>
-              <a:t>Игра заканчивается, когда колода запросов больше не позволяет</a:t>
-            </a:r>
-          </a:p>
-          <a:p>
-            <a:pPr>
-              <a:spcBef>
-                <a:spcPts val="0"/>
-              </a:spcBef>
-              <a:spcAft>
-                <a:spcPts val="200"/>
-              </a:spcAft>
-            </a:pPr>
-            <a:r>
-              <a:rPr sz="1100" b="0">
-                <a:solidFill>
-                  <a:srgbClr val="1A1A1A"/>
-                </a:solidFill>
-                <a:latin typeface="Arial"/>
-              </a:rPr>
-              <a:t>начать раунд (закончилась или осталась одна карта без пары).</a:t>
-            </a:r>
-          </a:p>
-          <a:p>
-            <a:pPr>
-              <a:spcBef>
-                <a:spcPts val="0"/>
-              </a:spcBef>
-              <a:spcAft>
-                <a:spcPts val="200"/>
-              </a:spcAft>
-            </a:pPr>
-            <a:r>
-              <a:rPr sz="1100" b="0">
-                <a:solidFill>
-                  <a:srgbClr val="1A1A1A"/>
-                </a:solidFill>
-                <a:latin typeface="Arial"/>
-              </a:rPr>
-              <a:t>1. Каждый считает карты запросов перед собой.</a:t>
-            </a:r>
-          </a:p>
-          <a:p>
-            <a:pPr>
-              <a:spcBef>
-                <a:spcPts val="0"/>
-              </a:spcBef>
-              <a:spcAft>
-                <a:spcPts val="200"/>
-              </a:spcAft>
-            </a:pPr>
-            <a:r>
-              <a:rPr sz="1100" b="0">
-                <a:solidFill>
-                  <a:srgbClr val="1A1A1A"/>
-                </a:solidFill>
-                <a:latin typeface="Arial"/>
-              </a:rPr>
-              <a:t>2. Побеждает игрок с наибольшим числом таких карт.</a:t>
-            </a:r>
-          </a:p>
-          <a:p>
-            <a:pPr>
-              <a:spcBef>
-                <a:spcPts val="0"/>
-              </a:spcBef>
-              <a:spcAft>
-                <a:spcPts val="200"/>
-              </a:spcAft>
-            </a:pPr>
-            <a:r>
-              <a:rPr sz="1100" b="0">
-                <a:solidFill>
-                  <a:srgbClr val="1A1A1A"/>
-                </a:solidFill>
-                <a:latin typeface="Arial"/>
-              </a:rPr>
-              <a:t>При ничьей – совместная победа.</a:t>
-            </a:r>
-          </a:p>
-        </p:txBody>
-      </p:sp>
-      <p:sp>
-        <p:nvSpPr>
-          <p:cNvPr id="16" name="TextBox 15"/>
-          <p:cNvSpPr txBox="1"/>
-          <p:nvPr/>
-        </p:nvSpPr>
-        <p:spPr>
-          <a:xfrm>
-            <a:off x="432000" y="9604117"/>
-            <a:ext cx="6696000" cy="288000"/>
-          </a:xfrm>
-          <a:prstGeom prst="rect">
-            <a:avLst/>
-          </a:prstGeom>
-          <a:noFill/>
-        </p:spPr>
-        <p:txBody>
-          <a:bodyPr wrap="square" anchor="t" lIns="0" rIns="0" tIns="0" bIns="0">
-            <a:spAutoFit/>
-          </a:bodyPr>
-          <a:lstStyle/>
-          <a:p>
-            <a:r>
-              <a:rPr sz="1200" b="1">
-                <a:solidFill>
-                  <a:srgbClr val="2E5A88"/>
-                </a:solidFill>
-                <a:latin typeface="Arial"/>
-              </a:rPr>
-              <a:t>ЧАСТЫЕ ВОПРОСЫ</a:t>
-            </a:r>
-          </a:p>
-        </p:txBody>
-      </p:sp>
     </p:spTree>
   </p:cSld>
   <p:clrMapOvr>
@@ -5854,7 +5483,41 @@
         <p:spPr>
           <a:xfrm>
             <a:off x="432000" y="432000"/>
-            <a:ext cx="6696000" cy="1634400"/>
+            <a:ext cx="6696000" cy="288000"/>
+          </a:xfrm>
+          <a:prstGeom prst="rect">
+            <a:avLst/>
+          </a:prstGeom>
+          <a:noFill/>
+        </p:spPr>
+        <p:txBody>
+          <a:bodyPr wrap="square" anchor="t" lIns="0" rIns="0" tIns="0" bIns="0">
+            <a:spAutoFit/>
+          </a:bodyPr>
+          <a:lstStyle/>
+          <a:p>
+            <a:r>
+              <a:rPr sz="1200" b="1" i="0">
+                <a:solidFill>
+                  <a:srgbClr val="2E5A88"/>
+                </a:solidFill>
+                <a:latin typeface="Arial"/>
+              </a:rPr>
+              <a:t>КОНТАКТЫ</a:t>
+            </a:r>
+          </a:p>
+        </p:txBody>
+      </p:sp>
+      <p:sp>
+        <p:nvSpPr>
+          <p:cNvPr id="3" name="TextBox 2"/>
+          <p:cNvSpPr txBox="1"/>
+          <p:nvPr/>
+        </p:nvSpPr>
+        <p:spPr>
+          <a:xfrm>
+            <a:off x="432000" y="720000"/>
+            <a:ext cx="6696000" cy="295200"/>
           </a:xfrm>
           <a:prstGeom prst="rect">
             <a:avLst/>
@@ -5876,463 +5539,17 @@
               </a:spcAft>
             </a:pPr>
             <a:r>
-              <a:rPr sz="1000" b="0">
+              <a:rPr sz="1000" b="0" i="0">
                 <a:solidFill>
                   <a:srgbClr val="1A1A1A"/>
                 </a:solidFill>
                 <a:latin typeface="Arial"/>
               </a:rPr>
-              <a:t>? Можно ли кинуть «Ты восхитителен» себе?  Нет. Только другому.</a:t>
-            </a:r>
-          </a:p>
-          <a:p>
-            <a:pPr>
-              <a:spcBef>
-                <a:spcPts val="0"/>
-              </a:spcBef>
-              <a:spcAft>
-                <a:spcPts val="200"/>
-              </a:spcAft>
-            </a:pPr>
-            <a:r>
-              <a:rPr sz="1000" b="0">
-                <a:solidFill>
-                  <a:srgbClr val="1A1A1A"/>
-                </a:solidFill>
-                <a:latin typeface="Arial"/>
-              </a:rPr>
-              <a:t>? Карта упала между двумя – чей голос?  Решает владелец карты.</a:t>
-            </a:r>
-          </a:p>
-          <a:p>
-            <a:pPr>
-              <a:spcBef>
-                <a:spcPts val="0"/>
-              </a:spcBef>
-              <a:spcAft>
-                <a:spcPts val="200"/>
-              </a:spcAft>
-            </a:pPr>
-            <a:r>
-              <a:rPr sz="1000" b="0">
-                <a:solidFill>
-                  <a:srgbClr val="1A1A1A"/>
-                </a:solidFill>
-                <a:latin typeface="Arial"/>
-              </a:rPr>
-              <a:t>? Копаться в разложенных буквах?  Нет. Только брать сверху/с края,</a:t>
-            </a:r>
-          </a:p>
-          <a:p>
-            <a:pPr>
-              <a:spcBef>
-                <a:spcPts val="0"/>
-              </a:spcBef>
-              <a:spcAft>
-                <a:spcPts val="200"/>
-              </a:spcAft>
-            </a:pPr>
-            <a:r>
-              <a:rPr sz="1000" b="0">
-                <a:solidFill>
-                  <a:srgbClr val="1A1A1A"/>
-                </a:solidFill>
-                <a:latin typeface="Arial"/>
-              </a:rPr>
-              <a:t>  одной рукой по 1 карте. Вторая рука – только держать взятое.</a:t>
-            </a:r>
-          </a:p>
-          <a:p>
-            <a:pPr>
-              <a:spcBef>
-                <a:spcPts val="0"/>
-              </a:spcBef>
-              <a:spcAft>
-                <a:spcPts val="200"/>
-              </a:spcAft>
-            </a:pPr>
-            <a:r>
-              <a:rPr sz="1000" b="0">
-                <a:solidFill>
-                  <a:srgbClr val="1A1A1A"/>
-                </a:solidFill>
-                <a:latin typeface="Arial"/>
-              </a:rPr>
-              <a:t>? Когда переставать брать буквы?  Когда хватит на ваш ответ.</a:t>
-            </a:r>
-          </a:p>
-          <a:p>
-            <a:pPr>
-              <a:spcBef>
-                <a:spcPts val="0"/>
-              </a:spcBef>
-              <a:spcAft>
-                <a:spcPts val="200"/>
-              </a:spcAft>
-            </a:pPr>
-            <a:r>
-              <a:rPr sz="1000" b="0">
-                <a:solidFill>
-                  <a:srgbClr val="1A1A1A"/>
-                </a:solidFill>
-                <a:latin typeface="Arial"/>
-              </a:rPr>
-              <a:t>? Сколько джокеров можно сыграть?  Сколько угодно. Зал реже</a:t>
-            </a:r>
-          </a:p>
-          <a:p>
-            <a:pPr>
-              <a:spcBef>
-                <a:spcPts val="0"/>
-              </a:spcBef>
-              <a:spcAft>
-                <a:spcPts val="200"/>
-              </a:spcAft>
-            </a:pPr>
-            <a:r>
-              <a:rPr sz="1000" b="0">
-                <a:solidFill>
-                  <a:srgbClr val="1A1A1A"/>
-                </a:solidFill>
-                <a:latin typeface="Arial"/>
-              </a:rPr>
-              <a:t>  голосует за нечитаемый ответ.</a:t>
-            </a:r>
-          </a:p>
-        </p:txBody>
-      </p:sp>
-      <p:sp>
-        <p:nvSpPr>
-          <p:cNvPr id="3" name="TextBox 2"/>
-          <p:cNvSpPr txBox="1"/>
-          <p:nvPr/>
-        </p:nvSpPr>
-        <p:spPr>
-          <a:xfrm>
-            <a:off x="432000" y="2102400"/>
-            <a:ext cx="6696000" cy="288000"/>
-          </a:xfrm>
-          <a:prstGeom prst="rect">
-            <a:avLst/>
-          </a:prstGeom>
-          <a:noFill/>
-        </p:spPr>
-        <p:txBody>
-          <a:bodyPr wrap="square" anchor="t" lIns="0" rIns="0" tIns="0" bIns="0">
-            <a:spAutoFit/>
-          </a:bodyPr>
-          <a:lstStyle/>
-          <a:p>
-            <a:r>
-              <a:rPr sz="1200" b="1">
-                <a:solidFill>
-                  <a:srgbClr val="2E5A88"/>
-                </a:solidFill>
-                <a:latin typeface="Arial"/>
-              </a:rPr>
-              <a:t>СОЗДАТЕЛИ</a:t>
-            </a:r>
-          </a:p>
-        </p:txBody>
-      </p:sp>
-      <p:sp>
-        <p:nvSpPr>
-          <p:cNvPr id="4" name="TextBox 3"/>
-          <p:cNvSpPr txBox="1"/>
-          <p:nvPr/>
-        </p:nvSpPr>
-        <p:spPr>
-          <a:xfrm>
-            <a:off x="432000" y="2390400"/>
-            <a:ext cx="6696000" cy="964800"/>
-          </a:xfrm>
-          <a:prstGeom prst="rect">
-            <a:avLst/>
-          </a:prstGeom>
-          <a:noFill/>
-        </p:spPr>
-        <p:txBody>
-          <a:bodyPr wrap="square" anchor="t" lIns="0" rIns="0" tIns="0" bIns="0">
-            <a:spAutoFit/>
-          </a:bodyPr>
-          <a:lstStyle/>
-          <a:p>
-            <a:pPr>
-              <a:spcBef>
-                <a:spcPts val="0"/>
-              </a:spcBef>
-              <a:spcAft>
-                <a:spcPts val="200"/>
-              </a:spcAft>
-            </a:pPr>
-            <a:r>
-              <a:rPr sz="1000" b="0">
-                <a:solidFill>
-                  <a:srgbClr val="1A1A1A"/>
-                </a:solidFill>
-                <a:latin typeface="Arial"/>
-              </a:rPr>
-              <a:t>Автор: Юрий Ямщиков</a:t>
-            </a:r>
-          </a:p>
-          <a:p>
-            <a:pPr>
-              <a:spcBef>
-                <a:spcPts val="0"/>
-              </a:spcBef>
-              <a:spcAft>
-                <a:spcPts val="200"/>
-              </a:spcAft>
-            </a:pPr>
-            <a:r>
-              <a:rPr sz="1000" b="0">
-                <a:solidFill>
-                  <a:srgbClr val="1A1A1A"/>
-                </a:solidFill>
-                <a:latin typeface="Arial"/>
-              </a:rPr>
-              <a:t>Редакция / развитие: [плейсхолдер]</a:t>
-            </a:r>
-          </a:p>
-          <a:p>
-            <a:pPr>
-              <a:spcBef>
-                <a:spcPts val="0"/>
-              </a:spcBef>
-              <a:spcAft>
-                <a:spcPts val="200"/>
-              </a:spcAft>
-            </a:pPr>
-            <a:r>
-              <a:rPr sz="1000" b="0">
-                <a:solidFill>
-                  <a:srgbClr val="1A1A1A"/>
-                </a:solidFill>
-                <a:latin typeface="Arial"/>
-              </a:rPr>
-              <a:t>Версия правил 0.6</a:t>
-            </a:r>
-          </a:p>
-          <a:p>
-            <a:pPr>
-              <a:spcBef>
-                <a:spcPts val="0"/>
-              </a:spcBef>
-              <a:spcAft>
-                <a:spcPts val="200"/>
-              </a:spcAft>
-            </a:pPr>
-            <a:r>
-              <a:rPr sz="1000" b="0">
-                <a:solidFill>
-                  <a:srgbClr val="1A1A1A"/>
-                </a:solidFill>
-                <a:latin typeface="Arial"/>
-              </a:rPr>
-              <a:t>yury.yamshchikov@gmail.com</a:t>
-            </a:r>
-          </a:p>
-        </p:txBody>
-      </p:sp>
-      <p:sp>
-        <p:nvSpPr>
-          <p:cNvPr id="5" name="TextBox 4"/>
-          <p:cNvSpPr txBox="1"/>
-          <p:nvPr/>
-        </p:nvSpPr>
-        <p:spPr>
-          <a:xfrm>
-            <a:off x="432000" y="3391200"/>
-            <a:ext cx="6696000" cy="288000"/>
-          </a:xfrm>
-          <a:prstGeom prst="rect">
-            <a:avLst/>
-          </a:prstGeom>
-          <a:noFill/>
-        </p:spPr>
-        <p:txBody>
-          <a:bodyPr wrap="square" anchor="t" lIns="0" rIns="0" tIns="0" bIns="0">
-            <a:spAutoFit/>
-          </a:bodyPr>
-          <a:lstStyle/>
-          <a:p>
-            <a:r>
-              <a:rPr sz="1200" b="1">
-                <a:solidFill>
-                  <a:srgbClr val="2E5A88"/>
-                </a:solidFill>
-                <a:latin typeface="Arial"/>
-              </a:rPr>
-              <a:t>ПАМЯТКА РАУНДА</a:t>
-            </a:r>
-          </a:p>
-        </p:txBody>
-      </p:sp>
-      <p:sp>
-        <p:nvSpPr>
-          <p:cNvPr id="6" name="TextBox 5"/>
-          <p:cNvSpPr txBox="1"/>
-          <p:nvPr/>
-        </p:nvSpPr>
-        <p:spPr>
-          <a:xfrm>
-            <a:off x="432000" y="3679200"/>
-            <a:ext cx="6696000" cy="1025280"/>
-          </a:xfrm>
-          <a:prstGeom prst="rect">
-            <a:avLst/>
-          </a:prstGeom>
-          <a:noFill/>
-        </p:spPr>
-        <p:txBody>
-          <a:bodyPr wrap="square" anchor="t" lIns="0" rIns="0" tIns="0" bIns="0">
-            <a:spAutoFit/>
-          </a:bodyPr>
-          <a:lstStyle/>
-          <a:p>
-            <a:pPr>
-              <a:spcBef>
-                <a:spcPts val="0"/>
-              </a:spcBef>
-              <a:spcAft>
-                <a:spcPts val="200"/>
-              </a:spcAft>
-            </a:pPr>
-            <a:r>
-              <a:rPr sz="1100" b="0">
-                <a:solidFill>
-                  <a:srgbClr val="1A1A1A"/>
-                </a:solidFill>
-                <a:latin typeface="Arial"/>
-              </a:rPr>
-              <a:t>1. Открыть зеркало-запрос</a:t>
-            </a:r>
-          </a:p>
-          <a:p>
-            <a:pPr>
-              <a:spcBef>
-                <a:spcPts val="0"/>
-              </a:spcBef>
-              <a:spcAft>
-                <a:spcPts val="200"/>
-              </a:spcAft>
-            </a:pPr>
-            <a:r>
-              <a:rPr sz="1100" b="0">
-                <a:solidFill>
-                  <a:srgbClr val="1A1A1A"/>
-                </a:solidFill>
-                <a:latin typeface="Arial"/>
-              </a:rPr>
-              <a:t>2. Взять буквы из центра (одна рука, по 1) и собрать ответ</a:t>
-            </a:r>
-          </a:p>
-          <a:p>
-            <a:pPr>
-              <a:spcBef>
-                <a:spcPts val="0"/>
-              </a:spcBef>
-              <a:spcAft>
-                <a:spcPts val="200"/>
-              </a:spcAft>
-            </a:pPr>
-            <a:r>
-              <a:rPr sz="1100" b="0">
-                <a:solidFill>
-                  <a:srgbClr val="1A1A1A"/>
-                </a:solidFill>
-                <a:latin typeface="Arial"/>
-              </a:rPr>
-              <a:t>3. Кинуть «Ты восхитителен»</a:t>
-            </a:r>
-          </a:p>
-          <a:p>
-            <a:pPr>
-              <a:spcBef>
-                <a:spcPts val="0"/>
-              </a:spcBef>
-              <a:spcAft>
-                <a:spcPts val="200"/>
-              </a:spcAft>
-            </a:pPr>
-            <a:r>
-              <a:rPr sz="1100" b="0">
-                <a:solidFill>
-                  <a:srgbClr val="1A1A1A"/>
-                </a:solidFill>
-                <a:latin typeface="Arial"/>
-              </a:rPr>
-              <a:t>4. Все буквы – в центр, перемешать, раскидать лицом вверх</a:t>
-            </a:r>
-          </a:p>
-        </p:txBody>
-      </p:sp>
-      <p:sp>
-        <p:nvSpPr>
-          <p:cNvPr id="7" name="TextBox 6"/>
-          <p:cNvSpPr txBox="1"/>
-          <p:nvPr/>
-        </p:nvSpPr>
-        <p:spPr>
-          <a:xfrm>
-            <a:off x="432000" y="4740480"/>
-            <a:ext cx="6696000" cy="310320"/>
-          </a:xfrm>
-          <a:prstGeom prst="rect">
-            <a:avLst/>
-          </a:prstGeom>
-          <a:noFill/>
-        </p:spPr>
-        <p:txBody>
-          <a:bodyPr wrap="square" anchor="t" lIns="0" rIns="0" tIns="0" bIns="0">
-            <a:spAutoFit/>
-          </a:bodyPr>
-          <a:lstStyle/>
-          <a:p>
-            <a:pPr>
-              <a:spcBef>
-                <a:spcPts val="0"/>
-              </a:spcBef>
-              <a:spcAft>
-                <a:spcPts val="200"/>
-              </a:spcAft>
-            </a:pPr>
-            <a:r>
-              <a:rPr sz="1100" b="0">
-                <a:solidFill>
-                  <a:srgbClr val="1A1A1A"/>
-                </a:solidFill>
-                <a:latin typeface="Arial"/>
-              </a:rPr>
-              <a:t>После раунда все карты букв снова лежат в центре лицом вверх.</a:t>
-            </a:r>
-          </a:p>
-        </p:txBody>
-      </p:sp>
-      <p:pic>
-        <p:nvPicPr>
-          <p:cNvPr id="8" name="Picture 7" descr="setup-table.png"/>
-          <p:cNvPicPr>
-            <a:picLocks noChangeAspect="1"/>
-          </p:cNvPicPr>
-          <p:nvPr/>
-        </p:nvPicPr>
-        <p:blipFill>
-          <a:blip r:embed="rId2"/>
-          <a:stretch>
-            <a:fillRect/>
-          </a:stretch>
-        </p:blipFill>
-        <p:spPr>
-          <a:xfrm>
-            <a:off x="432000" y="5086800"/>
-            <a:ext cx="6696000" cy="4276556"/>
-          </a:xfrm>
-          <a:prstGeom prst="rect">
-            <a:avLst/>
-          </a:prstGeom>
-        </p:spPr>
-      </p:pic>
+              <a:t>Контакты автора: t.me/tanion, vk.ru/tanion, yury@nxt.ru, +79213189331 (не стесняйтесь звонить / писать при возникновении вопросов)</a:t>
+            </a:r>
+          </a:p>
+        </p:txBody>
+      </p:sp>
     </p:spTree>
   </p:cSld>
   <p:clrMapOvr>

</xml_diff>